<commit_message>
docs: align presentation with Schalk branding and enhance recovery documentation
</commit_message>
<xml_diff>
--- a/BigQuery_Housekeeping_Process.pptx
+++ b/BigQuery_Housekeeping_Process.pptx
@@ -3094,57 +3094,14 @@
       <p:grpSpPr/>
       <p:sp>
         <p:nvSpPr>
-          <p:cNvPr id="2" name="Rectangle 1"/>
-          <p:cNvSpPr/>
+          <p:cNvPr id="2" name="TextBox 1"/>
+          <p:cNvSpPr txBox="1"/>
           <p:nvPr/>
         </p:nvSpPr>
         <p:spPr>
           <a:xfrm>
-            <a:off x="0" y="0"/>
-            <a:ext cx="12191695" cy="6858000"/>
-          </a:xfrm>
-          <a:prstGeom prst="rect">
-            <a:avLst/>
-          </a:prstGeom>
-          <a:solidFill>
-            <a:srgbClr val="102632"/>
-          </a:solidFill>
-          <a:ln>
-            <a:noFill/>
-          </a:ln>
-        </p:spPr>
-        <p:style>
-          <a:lnRef idx="1">
-            <a:schemeClr val="accent1"/>
-          </a:lnRef>
-          <a:fillRef idx="3">
-            <a:schemeClr val="accent1"/>
-          </a:fillRef>
-          <a:effectRef idx="2">
-            <a:schemeClr val="accent1"/>
-          </a:effectRef>
-          <a:fontRef idx="minor">
-            <a:schemeClr val="lt1"/>
-          </a:fontRef>
-        </p:style>
-        <p:txBody>
-          <a:bodyPr rtlCol="0" anchor="ctr"/>
-          <a:lstStyle/>
-          <a:p>
-            <a:pPr algn="ctr"/>
-          </a:p>
-        </p:txBody>
-      </p:sp>
-      <p:sp>
-        <p:nvSpPr>
-          <p:cNvPr id="3" name="TextBox 2"/>
-          <p:cNvSpPr txBox="1"/>
-          <p:nvPr/>
-        </p:nvSpPr>
-        <p:spPr>
-          <a:xfrm>
-            <a:off x="0" y="2286000"/>
-            <a:ext cx="12191695" cy="1371600"/>
+            <a:off x="457200" y="1828800"/>
+            <a:ext cx="10972800" cy="1371600"/>
           </a:xfrm>
           <a:prstGeom prst="rect">
             <a:avLst/>
@@ -3156,31 +3113,33 @@
             <a:spAutoFit/>
           </a:bodyPr>
           <a:lstStyle/>
-          <a:p/>
-          <a:p>
-            <a:pPr algn="ctr">
-              <a:defRPr b="1" sz="5400">
-                <a:solidFill>
-                  <a:srgbClr val="20FC8F"/>
-                </a:solidFill>
-              </a:defRPr>
-            </a:pPr>
-            <a:r>
-              <a:t>BigQuery Data Estate Housekeeping</a:t>
-            </a:r>
-          </a:p>
-        </p:txBody>
-      </p:sp>
-      <p:sp>
-        <p:nvSpPr>
-          <p:cNvPr id="4" name="TextBox 3"/>
+          <a:p>
+            <a:pPr algn="l"/>
+          </a:p>
+          <a:p>
+            <a:pPr algn="l"/>
+            <a:r>
+              <a:rPr sz="6000" b="1">
+                <a:solidFill>
+                  <a:srgbClr val="1A73E8"/>
+                </a:solidFill>
+                <a:latin typeface="Montserrat"/>
+              </a:rPr>
+              <a:t>BigQuery Housekeeping</a:t>
+            </a:r>
+          </a:p>
+        </p:txBody>
+      </p:sp>
+      <p:sp>
+        <p:nvSpPr>
+          <p:cNvPr id="3" name="TextBox 2"/>
           <p:cNvSpPr txBox="1"/>
           <p:nvPr/>
         </p:nvSpPr>
         <p:spPr>
           <a:xfrm>
-            <a:off x="0" y="3657600"/>
-            <a:ext cx="12191695" cy="914400"/>
+            <a:off x="457200" y="2926080"/>
+            <a:ext cx="10972800" cy="914400"/>
           </a:xfrm>
           <a:prstGeom prst="rect">
             <a:avLst/>
@@ -3192,29 +3151,57 @@
             <a:spAutoFit/>
           </a:bodyPr>
           <a:lstStyle/>
-          <a:p/>
-          <a:p>
-            <a:pPr algn="ctr">
-              <a:defRPr sz="2800">
-                <a:solidFill>
-                  <a:srgbClr val="FFFFFF"/>
-                </a:solidFill>
-              </a:defRPr>
-            </a:pPr>
-            <a:r>
-              <a:t>Automated 'Scream Test' &amp; Defensible Deletion Framework</a:t>
-            </a:r>
-          </a:p>
-          <a:p>
-            <a:pPr algn="ctr">
-              <a:defRPr sz="2000">
-                <a:solidFill>
-                  <a:srgbClr val="C8C8C8"/>
-                </a:solidFill>
-              </a:defRPr>
-            </a:pPr>
-            <a:r>
-              <a:t>Alan Dodd | Cloud Infrastructure Lead</a:t>
+          <a:p>
+            <a:pPr algn="l"/>
+          </a:p>
+          <a:p>
+            <a:pPr algn="l"/>
+            <a:r>
+              <a:rPr sz="2800" b="0">
+                <a:solidFill>
+                  <a:srgbClr val="5A6675"/>
+                </a:solidFill>
+                <a:latin typeface="Open Sans"/>
+              </a:rPr>
+              <a:t>Data Estate Decommissioning &amp; Scream Test Framework</a:t>
+            </a:r>
+          </a:p>
+        </p:txBody>
+      </p:sp>
+      <p:sp>
+        <p:nvSpPr>
+          <p:cNvPr id="4" name="TextBox 3"/>
+          <p:cNvSpPr txBox="1"/>
+          <p:nvPr/>
+        </p:nvSpPr>
+        <p:spPr>
+          <a:xfrm>
+            <a:off x="457200" y="5943600"/>
+            <a:ext cx="10972800" cy="457200"/>
+          </a:xfrm>
+          <a:prstGeom prst="rect">
+            <a:avLst/>
+          </a:prstGeom>
+          <a:noFill/>
+        </p:spPr>
+        <p:txBody>
+          <a:bodyPr wrap="none">
+            <a:spAutoFit/>
+          </a:bodyPr>
+          <a:lstStyle/>
+          <a:p>
+            <a:pPr algn="l"/>
+          </a:p>
+          <a:p>
+            <a:pPr algn="l"/>
+            <a:r>
+              <a:rPr sz="1400" b="1">
+                <a:solidFill>
+                  <a:srgbClr val="1A73E8"/>
+                </a:solidFill>
+                <a:latin typeface="Montserrat"/>
+              </a:rPr>
+              <a:t>EXECUTIVE REVIEW  ·  CLOUD FINOPS  ·  JUNE 2026</a:t>
             </a:r>
           </a:p>
         </p:txBody>
@@ -3239,100 +3226,14 @@
       <p:grpSpPr/>
       <p:sp>
         <p:nvSpPr>
-          <p:cNvPr id="2" name="Rectangle 1"/>
-          <p:cNvSpPr/>
+          <p:cNvPr id="2" name="TextBox 1"/>
+          <p:cNvSpPr txBox="1"/>
           <p:nvPr/>
         </p:nvSpPr>
         <p:spPr>
           <a:xfrm>
-            <a:off x="0" y="0"/>
-            <a:ext cx="12191695" cy="731520"/>
-          </a:xfrm>
-          <a:prstGeom prst="rect">
-            <a:avLst/>
-          </a:prstGeom>
-          <a:solidFill>
-            <a:srgbClr val="161923"/>
-          </a:solidFill>
-          <a:ln>
-            <a:noFill/>
-          </a:ln>
-        </p:spPr>
-        <p:style>
-          <a:lnRef idx="1">
-            <a:schemeClr val="accent1"/>
-          </a:lnRef>
-          <a:fillRef idx="3">
-            <a:schemeClr val="accent1"/>
-          </a:fillRef>
-          <a:effectRef idx="2">
-            <a:schemeClr val="accent1"/>
-          </a:effectRef>
-          <a:fontRef idx="minor">
-            <a:schemeClr val="lt1"/>
-          </a:fontRef>
-        </p:style>
-        <p:txBody>
-          <a:bodyPr rtlCol="0" anchor="ctr"/>
-          <a:lstStyle/>
-          <a:p>
-            <a:pPr algn="ctr"/>
-          </a:p>
-        </p:txBody>
-      </p:sp>
-      <p:sp>
-        <p:nvSpPr>
-          <p:cNvPr id="3" name="Rectangle 2"/>
-          <p:cNvSpPr/>
-          <p:nvPr/>
-        </p:nvSpPr>
-        <p:spPr>
-          <a:xfrm>
-            <a:off x="0" y="731520"/>
-            <a:ext cx="12191695" cy="45720"/>
-          </a:xfrm>
-          <a:prstGeom prst="rect">
-            <a:avLst/>
-          </a:prstGeom>
-          <a:solidFill>
-            <a:srgbClr val="20FC8F"/>
-          </a:solidFill>
-          <a:ln>
-            <a:noFill/>
-          </a:ln>
-        </p:spPr>
-        <p:style>
-          <a:lnRef idx="1">
-            <a:schemeClr val="accent1"/>
-          </a:lnRef>
-          <a:fillRef idx="3">
-            <a:schemeClr val="accent1"/>
-          </a:fillRef>
-          <a:effectRef idx="2">
-            <a:schemeClr val="accent1"/>
-          </a:effectRef>
-          <a:fontRef idx="minor">
-            <a:schemeClr val="lt1"/>
-          </a:fontRef>
-        </p:style>
-        <p:txBody>
-          <a:bodyPr rtlCol="0" anchor="ctr"/>
-          <a:lstStyle/>
-          <a:p>
-            <a:pPr algn="ctr"/>
-          </a:p>
-        </p:txBody>
-      </p:sp>
-      <p:sp>
-        <p:nvSpPr>
-          <p:cNvPr id="4" name="TextBox 3"/>
-          <p:cNvSpPr txBox="1"/>
-          <p:nvPr/>
-        </p:nvSpPr>
-        <p:spPr>
-          <a:xfrm>
-            <a:off x="457200" y="0"/>
-            <a:ext cx="11277295" cy="731520"/>
+            <a:off x="457200" y="274320"/>
+            <a:ext cx="10972800" cy="914400"/>
           </a:xfrm>
           <a:prstGeom prst="rect">
             <a:avLst/>
@@ -3345,29 +3246,32 @@
           </a:bodyPr>
           <a:lstStyle/>
           <a:p>
-            <a:pPr algn="l">
-              <a:defRPr sz="3600" b="1">
-                <a:solidFill>
-                  <a:srgbClr val="FFFFFF"/>
-                </a:solidFill>
-              </a:defRPr>
-            </a:pPr>
-            <a:r>
-              <a:t>Objective: Addressing 'Zombie Data'</a:t>
-            </a:r>
-          </a:p>
-        </p:txBody>
-      </p:sp>
-      <p:sp>
-        <p:nvSpPr>
-          <p:cNvPr id="5" name="TextBox 4"/>
+            <a:pPr algn="l"/>
+          </a:p>
+          <a:p>
+            <a:pPr algn="l"/>
+            <a:r>
+              <a:rPr sz="4000" b="1">
+                <a:solidFill>
+                  <a:srgbClr val="16202E"/>
+                </a:solidFill>
+                <a:latin typeface="Montserrat"/>
+              </a:rPr>
+              <a:t>Where we stand</a:t>
+            </a:r>
+          </a:p>
+        </p:txBody>
+      </p:sp>
+      <p:sp>
+        <p:nvSpPr>
+          <p:cNvPr id="3" name="TextBox 2"/>
           <p:cNvSpPr txBox="1"/>
           <p:nvPr/>
         </p:nvSpPr>
         <p:spPr>
           <a:xfrm>
-            <a:off x="914400" y="1371600"/>
-            <a:ext cx="10362895" cy="4572000"/>
+            <a:off x="457200" y="1097280"/>
+            <a:ext cx="10972800" cy="914400"/>
           </a:xfrm>
           <a:prstGeom prst="rect">
             <a:avLst/>
@@ -3375,78 +3279,251 @@
           <a:noFill/>
         </p:spPr>
         <p:txBody>
-          <a:bodyPr wrap="square">
+          <a:bodyPr wrap="none">
             <a:spAutoFit/>
           </a:bodyPr>
           <a:lstStyle/>
-          <a:p/>
-          <a:p>
-            <a:pPr>
-              <a:spcBef>
-                <a:spcPts val="2000"/>
-              </a:spcBef>
-              <a:defRPr b="1" sz="2800">
-                <a:solidFill>
-                  <a:srgbClr val="0A6B35"/>
-                </a:solidFill>
-              </a:defRPr>
-            </a:pPr>
-            <a:r>
-              <a:t>Cost Optimization</a:t>
-            </a:r>
-          </a:p>
-          <a:p>
-            <a:pPr lvl="1">
-              <a:defRPr sz="2200"/>
-            </a:pPr>
-            <a:r>
-              <a:t>Removing redundant datasets to reduce logical storage overhead.</a:t>
-            </a:r>
-          </a:p>
-          <a:p>
-            <a:pPr>
-              <a:spcBef>
-                <a:spcPts val="2000"/>
-              </a:spcBef>
-              <a:defRPr b="1" sz="2800">
-                <a:solidFill>
-                  <a:srgbClr val="0A6B35"/>
-                </a:solidFill>
-              </a:defRPr>
-            </a:pPr>
-            <a:r>
-              <a:t>Risk Mitigation</a:t>
-            </a:r>
-          </a:p>
-          <a:p>
-            <a:pPr lvl="1">
-              <a:defRPr sz="2200"/>
-            </a:pPr>
-            <a:r>
-              <a:t>Reducing data footprint to align with GDPR and THG retention policies.</a:t>
-            </a:r>
-          </a:p>
-          <a:p>
-            <a:pPr>
-              <a:spcBef>
-                <a:spcPts val="2000"/>
-              </a:spcBef>
-              <a:defRPr b="1" sz="2800">
-                <a:solidFill>
-                  <a:srgbClr val="0A6B35"/>
-                </a:solidFill>
-              </a:defRPr>
-            </a:pPr>
-            <a:r>
-              <a:t>Operational Hygiene</a:t>
-            </a:r>
-          </a:p>
-          <a:p>
-            <a:pPr lvl="1">
-              <a:defRPr sz="2200"/>
-            </a:pPr>
-            <a:r>
-              <a:t>Cleaning up 'Abandoned Prod' and 'Orphaned Test' datasets across both Orgs.</a:t>
+          <a:p>
+            <a:pPr algn="l"/>
+          </a:p>
+          <a:p>
+            <a:pPr algn="l"/>
+            <a:r>
+              <a:rPr sz="2200" b="0">
+                <a:solidFill>
+                  <a:srgbClr val="16202E"/>
+                </a:solidFill>
+                <a:latin typeface="Open Sans"/>
+              </a:rPr>
+              <a:t>A multi-stage process to eliminate 'Zombie Data' with zero risk to production operations.</a:t>
+            </a:r>
+          </a:p>
+        </p:txBody>
+      </p:sp>
+      <p:sp>
+        <p:nvSpPr>
+          <p:cNvPr id="4" name="TextBox 3"/>
+          <p:cNvSpPr txBox="1"/>
+          <p:nvPr/>
+        </p:nvSpPr>
+        <p:spPr>
+          <a:xfrm>
+            <a:off x="457200" y="2286000"/>
+            <a:ext cx="3657600" cy="914400"/>
+          </a:xfrm>
+          <a:prstGeom prst="rect">
+            <a:avLst/>
+          </a:prstGeom>
+          <a:noFill/>
+        </p:spPr>
+        <p:txBody>
+          <a:bodyPr wrap="none">
+            <a:spAutoFit/>
+          </a:bodyPr>
+          <a:lstStyle/>
+          <a:p>
+            <a:pPr algn="l"/>
+          </a:p>
+          <a:p>
+            <a:pPr algn="l"/>
+            <a:r>
+              <a:rPr sz="4400" b="1">
+                <a:solidFill>
+                  <a:srgbClr val="5A6675"/>
+                </a:solidFill>
+                <a:latin typeface="Montserrat"/>
+              </a:rPr>
+              <a:t>Audit</a:t>
+            </a:r>
+          </a:p>
+        </p:txBody>
+      </p:sp>
+      <p:sp>
+        <p:nvSpPr>
+          <p:cNvPr id="5" name="TextBox 4"/>
+          <p:cNvSpPr txBox="1"/>
+          <p:nvPr/>
+        </p:nvSpPr>
+        <p:spPr>
+          <a:xfrm>
+            <a:off x="457200" y="3017520"/>
+            <a:ext cx="3657600" cy="457200"/>
+          </a:xfrm>
+          <a:prstGeom prst="rect">
+            <a:avLst/>
+          </a:prstGeom>
+          <a:noFill/>
+        </p:spPr>
+        <p:txBody>
+          <a:bodyPr wrap="none">
+            <a:spAutoFit/>
+          </a:bodyPr>
+          <a:lstStyle/>
+          <a:p>
+            <a:pPr algn="l"/>
+          </a:p>
+          <a:p>
+            <a:pPr algn="l"/>
+            <a:r>
+              <a:rPr sz="1800" b="0">
+                <a:solidFill>
+                  <a:srgbClr val="16202E"/>
+                </a:solidFill>
+                <a:latin typeface="Open Sans"/>
+              </a:rPr>
+              <a:t>Deep history scan (180d+)</a:t>
+            </a:r>
+          </a:p>
+        </p:txBody>
+      </p:sp>
+      <p:sp>
+        <p:nvSpPr>
+          <p:cNvPr id="6" name="TextBox 5"/>
+          <p:cNvSpPr txBox="1"/>
+          <p:nvPr/>
+        </p:nvSpPr>
+        <p:spPr>
+          <a:xfrm>
+            <a:off x="4389120" y="2286000"/>
+            <a:ext cx="3657600" cy="914400"/>
+          </a:xfrm>
+          <a:prstGeom prst="rect">
+            <a:avLst/>
+          </a:prstGeom>
+          <a:noFill/>
+        </p:spPr>
+        <p:txBody>
+          <a:bodyPr wrap="none">
+            <a:spAutoFit/>
+          </a:bodyPr>
+          <a:lstStyle/>
+          <a:p>
+            <a:pPr algn="l"/>
+          </a:p>
+          <a:p>
+            <a:pPr algn="l"/>
+            <a:r>
+              <a:rPr sz="4400" b="1">
+                <a:solidFill>
+                  <a:srgbClr val="1A73E8"/>
+                </a:solidFill>
+                <a:latin typeface="Montserrat"/>
+              </a:rPr>
+              <a:t>Scream Test</a:t>
+            </a:r>
+          </a:p>
+        </p:txBody>
+      </p:sp>
+      <p:sp>
+        <p:nvSpPr>
+          <p:cNvPr id="7" name="TextBox 6"/>
+          <p:cNvSpPr txBox="1"/>
+          <p:nvPr/>
+        </p:nvSpPr>
+        <p:spPr>
+          <a:xfrm>
+            <a:off x="4389120" y="3017520"/>
+            <a:ext cx="3657600" cy="457200"/>
+          </a:xfrm>
+          <a:prstGeom prst="rect">
+            <a:avLst/>
+          </a:prstGeom>
+          <a:noFill/>
+        </p:spPr>
+        <p:txBody>
+          <a:bodyPr wrap="none">
+            <a:spAutoFit/>
+          </a:bodyPr>
+          <a:lstStyle/>
+          <a:p>
+            <a:pPr algn="l"/>
+          </a:p>
+          <a:p>
+            <a:pPr algn="l"/>
+            <a:r>
+              <a:rPr sz="1800" b="0">
+                <a:solidFill>
+                  <a:srgbClr val="16202E"/>
+                </a:solidFill>
+                <a:latin typeface="Open Sans"/>
+              </a:rPr>
+              <a:t>Access revocation monitoring</a:t>
+            </a:r>
+          </a:p>
+        </p:txBody>
+      </p:sp>
+      <p:sp>
+        <p:nvSpPr>
+          <p:cNvPr id="8" name="TextBox 7"/>
+          <p:cNvSpPr txBox="1"/>
+          <p:nvPr/>
+        </p:nvSpPr>
+        <p:spPr>
+          <a:xfrm>
+            <a:off x="8321040" y="2286000"/>
+            <a:ext cx="3657600" cy="914400"/>
+          </a:xfrm>
+          <a:prstGeom prst="rect">
+            <a:avLst/>
+          </a:prstGeom>
+          <a:noFill/>
+        </p:spPr>
+        <p:txBody>
+          <a:bodyPr wrap="none">
+            <a:spAutoFit/>
+          </a:bodyPr>
+          <a:lstStyle/>
+          <a:p>
+            <a:pPr algn="l"/>
+          </a:p>
+          <a:p>
+            <a:pPr algn="l"/>
+            <a:r>
+              <a:rPr sz="4400" b="1">
+                <a:solidFill>
+                  <a:srgbClr val="1E8E5A"/>
+                </a:solidFill>
+                <a:latin typeface="Montserrat"/>
+              </a:rPr>
+              <a:t>Recoverable</a:t>
+            </a:r>
+          </a:p>
+        </p:txBody>
+      </p:sp>
+      <p:sp>
+        <p:nvSpPr>
+          <p:cNvPr id="9" name="TextBox 8"/>
+          <p:cNvSpPr txBox="1"/>
+          <p:nvPr/>
+        </p:nvSpPr>
+        <p:spPr>
+          <a:xfrm>
+            <a:off x="8321040" y="3017520"/>
+            <a:ext cx="3657600" cy="457200"/>
+          </a:xfrm>
+          <a:prstGeom prst="rect">
+            <a:avLst/>
+          </a:prstGeom>
+          <a:noFill/>
+        </p:spPr>
+        <p:txBody>
+          <a:bodyPr wrap="none">
+            <a:spAutoFit/>
+          </a:bodyPr>
+          <a:lstStyle/>
+          <a:p>
+            <a:pPr algn="l"/>
+          </a:p>
+          <a:p>
+            <a:pPr algn="l"/>
+            <a:r>
+              <a:rPr sz="1800" b="0">
+                <a:solidFill>
+                  <a:srgbClr val="16202E"/>
+                </a:solidFill>
+                <a:latin typeface="Open Sans"/>
+              </a:rPr>
+              <a:t>7-day post-deletion window</a:t>
             </a:r>
           </a:p>
         </p:txBody>
@@ -3471,100 +3548,14 @@
       <p:grpSpPr/>
       <p:sp>
         <p:nvSpPr>
-          <p:cNvPr id="2" name="Rectangle 1"/>
-          <p:cNvSpPr/>
+          <p:cNvPr id="2" name="TextBox 1"/>
+          <p:cNvSpPr txBox="1"/>
           <p:nvPr/>
         </p:nvSpPr>
         <p:spPr>
           <a:xfrm>
-            <a:off x="0" y="0"/>
-            <a:ext cx="12191695" cy="731520"/>
-          </a:xfrm>
-          <a:prstGeom prst="rect">
-            <a:avLst/>
-          </a:prstGeom>
-          <a:solidFill>
-            <a:srgbClr val="161923"/>
-          </a:solidFill>
-          <a:ln>
-            <a:noFill/>
-          </a:ln>
-        </p:spPr>
-        <p:style>
-          <a:lnRef idx="1">
-            <a:schemeClr val="accent1"/>
-          </a:lnRef>
-          <a:fillRef idx="3">
-            <a:schemeClr val="accent1"/>
-          </a:fillRef>
-          <a:effectRef idx="2">
-            <a:schemeClr val="accent1"/>
-          </a:effectRef>
-          <a:fontRef idx="minor">
-            <a:schemeClr val="lt1"/>
-          </a:fontRef>
-        </p:style>
-        <p:txBody>
-          <a:bodyPr rtlCol="0" anchor="ctr"/>
-          <a:lstStyle/>
-          <a:p>
-            <a:pPr algn="ctr"/>
-          </a:p>
-        </p:txBody>
-      </p:sp>
-      <p:sp>
-        <p:nvSpPr>
-          <p:cNvPr id="3" name="Rectangle 2"/>
-          <p:cNvSpPr/>
-          <p:nvPr/>
-        </p:nvSpPr>
-        <p:spPr>
-          <a:xfrm>
-            <a:off x="0" y="731520"/>
-            <a:ext cx="12191695" cy="45720"/>
-          </a:xfrm>
-          <a:prstGeom prst="rect">
-            <a:avLst/>
-          </a:prstGeom>
-          <a:solidFill>
-            <a:srgbClr val="20FC8F"/>
-          </a:solidFill>
-          <a:ln>
-            <a:noFill/>
-          </a:ln>
-        </p:spPr>
-        <p:style>
-          <a:lnRef idx="1">
-            <a:schemeClr val="accent1"/>
-          </a:lnRef>
-          <a:fillRef idx="3">
-            <a:schemeClr val="accent1"/>
-          </a:fillRef>
-          <a:effectRef idx="2">
-            <a:schemeClr val="accent1"/>
-          </a:effectRef>
-          <a:fontRef idx="minor">
-            <a:schemeClr val="lt1"/>
-          </a:fontRef>
-        </p:style>
-        <p:txBody>
-          <a:bodyPr rtlCol="0" anchor="ctr"/>
-          <a:lstStyle/>
-          <a:p>
-            <a:pPr algn="ctr"/>
-          </a:p>
-        </p:txBody>
-      </p:sp>
-      <p:sp>
-        <p:nvSpPr>
-          <p:cNvPr id="4" name="TextBox 3"/>
-          <p:cNvSpPr txBox="1"/>
-          <p:nvPr/>
-        </p:nvSpPr>
-        <p:spPr>
-          <a:xfrm>
-            <a:off x="457200" y="0"/>
-            <a:ext cx="11277295" cy="731520"/>
+            <a:off x="457200" y="274320"/>
+            <a:ext cx="10972800" cy="914400"/>
           </a:xfrm>
           <a:prstGeom prst="rect">
             <a:avLst/>
@@ -3577,295 +3568,284 @@
           </a:bodyPr>
           <a:lstStyle/>
           <a:p>
-            <a:pPr>
-              <a:defRPr sz="3600" b="1">
-                <a:solidFill>
-                  <a:srgbClr val="FFFFFF"/>
-                </a:solidFill>
-              </a:defRPr>
-            </a:pPr>
-            <a:r>
-              <a:t>The 'Scream Test' Process</a:t>
-            </a:r>
-          </a:p>
-        </p:txBody>
-      </p:sp>
-      <p:sp>
-        <p:nvSpPr>
-          <p:cNvPr id="5" name="Rectangle 4"/>
-          <p:cNvSpPr/>
+            <a:pPr algn="l"/>
+          </a:p>
+          <a:p>
+            <a:pPr algn="l"/>
+            <a:r>
+              <a:rPr sz="4000" b="1">
+                <a:solidFill>
+                  <a:srgbClr val="16202E"/>
+                </a:solidFill>
+                <a:latin typeface="Montserrat"/>
+              </a:rPr>
+              <a:t>How to recover (Emergency Protocol)</a:t>
+            </a:r>
+          </a:p>
+        </p:txBody>
+      </p:sp>
+      <p:sp>
+        <p:nvSpPr>
+          <p:cNvPr id="3" name="TextBox 2"/>
+          <p:cNvSpPr txBox="1"/>
           <p:nvPr/>
         </p:nvSpPr>
         <p:spPr>
           <a:xfrm>
-            <a:off x="457200" y="1371600"/>
-            <a:ext cx="2743200" cy="3657600"/>
+            <a:off x="457200" y="1097280"/>
+            <a:ext cx="10972800" cy="914400"/>
           </a:xfrm>
           <a:prstGeom prst="rect">
             <a:avLst/>
           </a:prstGeom>
-          <a:solidFill>
-            <a:srgbClr val="F5F5F5"/>
-          </a:solidFill>
-          <a:ln>
-            <a:solidFill>
-              <a:srgbClr val="20FC8F"/>
-            </a:solidFill>
-          </a:ln>
+          <a:noFill/>
         </p:spPr>
-        <p:style>
-          <a:lnRef idx="1">
-            <a:schemeClr val="accent1"/>
-          </a:lnRef>
-          <a:fillRef idx="3">
-            <a:schemeClr val="accent1"/>
-          </a:fillRef>
-          <a:effectRef idx="2">
-            <a:schemeClr val="accent1"/>
-          </a:effectRef>
-          <a:fontRef idx="minor">
-            <a:schemeClr val="lt1"/>
-          </a:fontRef>
-        </p:style>
-        <p:txBody>
-          <a:bodyPr rtlCol="0" anchor="ctr" wrap="square"/>
-          <a:lstStyle/>
-          <a:p>
-            <a:pPr algn="ctr"/>
-          </a:p>
-          <a:p>
-            <a:pPr>
-              <a:defRPr b="1" sz="2400">
-                <a:solidFill>
-                  <a:srgbClr val="161923"/>
-                </a:solidFill>
-              </a:defRPr>
-            </a:pPr>
-            <a:r>
-              <a:t>1. Audit &amp; Identify</a:t>
-            </a:r>
-          </a:p>
-          <a:p>
-            <a:br/>
-            <a:pPr>
-              <a:defRPr sz="1800">
-                <a:solidFill>
-                  <a:srgbClr val="102632"/>
-                </a:solidFill>
-              </a:defRPr>
-            </a:pPr>
-            <a:r>
-              <a:t>Multi-layer analysis: Storage modified time vs. Query access history (180d).</a:t>
-            </a:r>
-          </a:p>
-        </p:txBody>
-      </p:sp>
-      <p:sp>
-        <p:nvSpPr>
-          <p:cNvPr id="6" name="Rectangle 5"/>
-          <p:cNvSpPr/>
+        <p:txBody>
+          <a:bodyPr wrap="none">
+            <a:spAutoFit/>
+          </a:bodyPr>
+          <a:lstStyle/>
+          <a:p>
+            <a:pPr algn="l"/>
+          </a:p>
+          <a:p>
+            <a:pPr algn="l"/>
+            <a:r>
+              <a:rPr sz="2200" b="0">
+                <a:solidFill>
+                  <a:srgbClr val="5A6675"/>
+                </a:solidFill>
+                <a:latin typeface="Open Sans"/>
+              </a:rPr>
+              <a:t>In the event of a 'Scream', access can be restored to any dataset in seconds.</a:t>
+            </a:r>
+          </a:p>
+        </p:txBody>
+      </p:sp>
+      <p:sp>
+        <p:nvSpPr>
+          <p:cNvPr id="4" name="TextBox 3"/>
+          <p:cNvSpPr txBox="1"/>
           <p:nvPr/>
         </p:nvSpPr>
         <p:spPr>
           <a:xfrm>
-            <a:off x="3291840" y="1371600"/>
-            <a:ext cx="2743200" cy="3657600"/>
+            <a:off x="457200" y="2286000"/>
+            <a:ext cx="10972800" cy="457200"/>
           </a:xfrm>
           <a:prstGeom prst="rect">
             <a:avLst/>
           </a:prstGeom>
-          <a:solidFill>
-            <a:srgbClr val="F5F5F5"/>
-          </a:solidFill>
-          <a:ln>
-            <a:solidFill>
-              <a:srgbClr val="20FC8F"/>
-            </a:solidFill>
-          </a:ln>
+          <a:noFill/>
         </p:spPr>
-        <p:style>
-          <a:lnRef idx="1">
-            <a:schemeClr val="accent1"/>
-          </a:lnRef>
-          <a:fillRef idx="3">
-            <a:schemeClr val="accent1"/>
-          </a:fillRef>
-          <a:effectRef idx="2">
-            <a:schemeClr val="accent1"/>
-          </a:effectRef>
-          <a:fontRef idx="minor">
-            <a:schemeClr val="lt1"/>
-          </a:fontRef>
-        </p:style>
-        <p:txBody>
-          <a:bodyPr rtlCol="0" anchor="ctr" wrap="square"/>
-          <a:lstStyle/>
-          <a:p>
-            <a:pPr algn="ctr"/>
-          </a:p>
-          <a:p>
-            <a:pPr>
-              <a:defRPr b="1" sz="2400">
-                <a:solidFill>
-                  <a:srgbClr val="161923"/>
-                </a:solidFill>
-              </a:defRPr>
-            </a:pPr>
-            <a:r>
-              <a:t>2. Backup &amp; Label</a:t>
-            </a:r>
-          </a:p>
-          <a:p>
-            <a:br/>
-            <a:pPr>
-              <a:defRPr sz="1800">
-                <a:solidFill>
-                  <a:srgbClr val="102632"/>
-                </a:solidFill>
-              </a:defRPr>
-            </a:pPr>
-            <a:r>
-              <a:t>Automated capture of dataset access policies to GCS prior to any modification.</a:t>
-            </a:r>
-          </a:p>
-        </p:txBody>
-      </p:sp>
-      <p:sp>
-        <p:nvSpPr>
-          <p:cNvPr id="7" name="Rectangle 6"/>
-          <p:cNvSpPr/>
+        <p:txBody>
+          <a:bodyPr wrap="none">
+            <a:spAutoFit/>
+          </a:bodyPr>
+          <a:lstStyle/>
+          <a:p>
+            <a:pPr algn="l"/>
+          </a:p>
+          <a:p>
+            <a:pPr algn="l"/>
+            <a:r>
+              <a:rPr sz="2400" b="1">
+                <a:solidFill>
+                  <a:srgbClr val="1A73E8"/>
+                </a:solidFill>
+                <a:latin typeface="Montserrat"/>
+              </a:rPr>
+              <a:t>1. Automated Restore</a:t>
+            </a:r>
+          </a:p>
+        </p:txBody>
+      </p:sp>
+      <p:sp>
+        <p:nvSpPr>
+          <p:cNvPr id="5" name="TextBox 4"/>
+          <p:cNvSpPr txBox="1"/>
           <p:nvPr/>
         </p:nvSpPr>
         <p:spPr>
           <a:xfrm>
-            <a:off x="6126480" y="1371600"/>
-            <a:ext cx="2743200" cy="3657600"/>
+            <a:off x="457200" y="2651760"/>
+            <a:ext cx="10972800" cy="731520"/>
           </a:xfrm>
           <a:prstGeom prst="rect">
             <a:avLst/>
           </a:prstGeom>
-          <a:solidFill>
-            <a:srgbClr val="F5F5F5"/>
-          </a:solidFill>
-          <a:ln>
-            <a:solidFill>
-              <a:srgbClr val="20FC8F"/>
-            </a:solidFill>
-          </a:ln>
+          <a:noFill/>
         </p:spPr>
-        <p:style>
-          <a:lnRef idx="1">
-            <a:schemeClr val="accent1"/>
-          </a:lnRef>
-          <a:fillRef idx="3">
-            <a:schemeClr val="accent1"/>
-          </a:fillRef>
-          <a:effectRef idx="2">
-            <a:schemeClr val="accent1"/>
-          </a:effectRef>
-          <a:fontRef idx="minor">
-            <a:schemeClr val="lt1"/>
-          </a:fontRef>
-        </p:style>
-        <p:txBody>
-          <a:bodyPr rtlCol="0" anchor="ctr" wrap="square"/>
-          <a:lstStyle/>
-          <a:p>
-            <a:pPr algn="ctr"/>
-          </a:p>
-          <a:p>
-            <a:pPr>
-              <a:defRPr b="1" sz="2400">
-                <a:solidFill>
-                  <a:srgbClr val="161923"/>
-                </a:solidFill>
-              </a:defRPr>
-            </a:pPr>
-            <a:r>
-              <a:t>3. Restrict (Scream Test)</a:t>
-            </a:r>
-          </a:p>
-          <a:p>
-            <a:br/>
-            <a:pPr>
-              <a:defRPr sz="1800">
-                <a:solidFill>
-                  <a:srgbClr val="102632"/>
-                </a:solidFill>
-              </a:defRPr>
-            </a:pPr>
-            <a:r>
-              <a:t>Removal of all non-OWNER access. Monitoring for 7-14 days for user impact.</a:t>
-            </a:r>
-          </a:p>
-        </p:txBody>
-      </p:sp>
-      <p:sp>
-        <p:nvSpPr>
-          <p:cNvPr id="8" name="Rectangle 7"/>
-          <p:cNvSpPr/>
+        <p:txBody>
+          <a:bodyPr wrap="none">
+            <a:spAutoFit/>
+          </a:bodyPr>
+          <a:lstStyle/>
+          <a:p>
+            <a:pPr algn="l"/>
+          </a:p>
+          <a:p>
+            <a:pPr algn="l"/>
+            <a:r>
+              <a:rPr sz="1800" b="0">
+                <a:solidFill>
+                  <a:srgbClr val="16202E"/>
+                </a:solidFill>
+                <a:latin typeface="Open Sans"/>
+              </a:rPr>
+              <a:t>Use the `bq_restore_access.py` tool. It automatically pulls the metadata backup from GCS and reapplies it.</a:t>
+            </a:r>
+          </a:p>
+        </p:txBody>
+      </p:sp>
+      <p:sp>
+        <p:nvSpPr>
+          <p:cNvPr id="6" name="TextBox 5"/>
+          <p:cNvSpPr txBox="1"/>
           <p:nvPr/>
         </p:nvSpPr>
         <p:spPr>
           <a:xfrm>
-            <a:off x="8961120" y="1371600"/>
-            <a:ext cx="2743200" cy="3657600"/>
+            <a:off x="457200" y="3657600"/>
+            <a:ext cx="10972800" cy="457200"/>
           </a:xfrm>
           <a:prstGeom prst="rect">
             <a:avLst/>
           </a:prstGeom>
-          <a:solidFill>
-            <a:srgbClr val="F5F5F5"/>
-          </a:solidFill>
-          <a:ln>
-            <a:solidFill>
-              <a:srgbClr val="20FC8F"/>
-            </a:solidFill>
-          </a:ln>
+          <a:noFill/>
         </p:spPr>
-        <p:style>
-          <a:lnRef idx="1">
-            <a:schemeClr val="accent1"/>
-          </a:lnRef>
-          <a:fillRef idx="3">
-            <a:schemeClr val="accent1"/>
-          </a:fillRef>
-          <a:effectRef idx="2">
-            <a:schemeClr val="accent1"/>
-          </a:effectRef>
-          <a:fontRef idx="minor">
-            <a:schemeClr val="lt1"/>
-          </a:fontRef>
-        </p:style>
-        <p:txBody>
-          <a:bodyPr rtlCol="0" anchor="ctr" wrap="square"/>
-          <a:lstStyle/>
-          <a:p>
-            <a:pPr algn="ctr"/>
-          </a:p>
-          <a:p>
-            <a:pPr>
-              <a:defRPr b="1" sz="2400">
-                <a:solidFill>
-                  <a:srgbClr val="161923"/>
-                </a:solidFill>
-              </a:defRPr>
-            </a:pPr>
-            <a:r>
-              <a:t>4. Decommission</a:t>
-            </a:r>
-          </a:p>
-          <a:p>
-            <a:br/>
-            <a:pPr>
-              <a:defRPr sz="1800">
-                <a:solidFill>
-                  <a:srgbClr val="102632"/>
-                </a:solidFill>
-              </a:defRPr>
-            </a:pPr>
-            <a:r>
-              <a:t>Permanent deletion of datasets that pass the monitoring period without 'screams'.</a:t>
+        <p:txBody>
+          <a:bodyPr wrap="none">
+            <a:spAutoFit/>
+          </a:bodyPr>
+          <a:lstStyle/>
+          <a:p>
+            <a:pPr algn="l"/>
+          </a:p>
+          <a:p>
+            <a:pPr algn="l"/>
+            <a:r>
+              <a:rPr sz="2400" b="1">
+                <a:solidFill>
+                  <a:srgbClr val="1A73E8"/>
+                </a:solidFill>
+                <a:latin typeface="Montserrat"/>
+              </a:rPr>
+              <a:t>2. Metadata Backups</a:t>
+            </a:r>
+          </a:p>
+        </p:txBody>
+      </p:sp>
+      <p:sp>
+        <p:nvSpPr>
+          <p:cNvPr id="7" name="TextBox 6"/>
+          <p:cNvSpPr txBox="1"/>
+          <p:nvPr/>
+        </p:nvSpPr>
+        <p:spPr>
+          <a:xfrm>
+            <a:off x="457200" y="4023360"/>
+            <a:ext cx="10972800" cy="731520"/>
+          </a:xfrm>
+          <a:prstGeom prst="rect">
+            <a:avLst/>
+          </a:prstGeom>
+          <a:noFill/>
+        </p:spPr>
+        <p:txBody>
+          <a:bodyPr wrap="none">
+            <a:spAutoFit/>
+          </a:bodyPr>
+          <a:lstStyle/>
+          <a:p>
+            <a:pPr algn="l"/>
+          </a:p>
+          <a:p>
+            <a:pPr algn="l"/>
+            <a:r>
+              <a:rPr sz="1800" b="0">
+                <a:solidFill>
+                  <a:srgbClr val="16202E"/>
+                </a:solidFill>
+                <a:latin typeface="Open Sans"/>
+              </a:rPr>
+              <a:t>All dataset policies are versioned in `gs://bq-admin-backup/backups/` before any change is made.</a:t>
+            </a:r>
+          </a:p>
+        </p:txBody>
+      </p:sp>
+      <p:sp>
+        <p:nvSpPr>
+          <p:cNvPr id="8" name="TextBox 7"/>
+          <p:cNvSpPr txBox="1"/>
+          <p:nvPr/>
+        </p:nvSpPr>
+        <p:spPr>
+          <a:xfrm>
+            <a:off x="457200" y="5029200"/>
+            <a:ext cx="10972800" cy="457200"/>
+          </a:xfrm>
+          <a:prstGeom prst="rect">
+            <a:avLst/>
+          </a:prstGeom>
+          <a:noFill/>
+        </p:spPr>
+        <p:txBody>
+          <a:bodyPr wrap="none">
+            <a:spAutoFit/>
+          </a:bodyPr>
+          <a:lstStyle/>
+          <a:p>
+            <a:pPr algn="l"/>
+          </a:p>
+          <a:p>
+            <a:pPr algn="l"/>
+            <a:r>
+              <a:rPr sz="2400" b="1">
+                <a:solidFill>
+                  <a:srgbClr val="1A73E8"/>
+                </a:solidFill>
+                <a:latin typeface="Montserrat"/>
+              </a:rPr>
+              <a:t>3. Org-Level Access</a:t>
+            </a:r>
+          </a:p>
+        </p:txBody>
+      </p:sp>
+      <p:sp>
+        <p:nvSpPr>
+          <p:cNvPr id="9" name="TextBox 8"/>
+          <p:cNvSpPr txBox="1"/>
+          <p:nvPr/>
+        </p:nvSpPr>
+        <p:spPr>
+          <a:xfrm>
+            <a:off x="457200" y="5394960"/>
+            <a:ext cx="10972800" cy="731520"/>
+          </a:xfrm>
+          <a:prstGeom prst="rect">
+            <a:avLst/>
+          </a:prstGeom>
+          <a:noFill/>
+        </p:spPr>
+        <p:txBody>
+          <a:bodyPr wrap="none">
+            <a:spAutoFit/>
+          </a:bodyPr>
+          <a:lstStyle/>
+          <a:p>
+            <a:pPr algn="l"/>
+          </a:p>
+          <a:p>
+            <a:pPr algn="l"/>
+            <a:r>
+              <a:rPr sz="1800" b="0">
+                <a:solidFill>
+                  <a:srgbClr val="16202E"/>
+                </a:solidFill>
+                <a:latin typeface="Open Sans"/>
+              </a:rPr>
+              <a:t>Org Admins retain persistence via Org-level IAM. You are never locked out of managing the resource.</a:t>
             </a:r>
           </a:p>
         </p:txBody>
@@ -3890,23 +3870,63 @@
       <p:grpSpPr/>
       <p:sp>
         <p:nvSpPr>
-          <p:cNvPr id="2" name="Rectangle 1"/>
+          <p:cNvPr id="2" name="TextBox 1"/>
+          <p:cNvSpPr txBox="1"/>
+          <p:nvPr/>
+        </p:nvSpPr>
+        <p:spPr>
+          <a:xfrm>
+            <a:off x="457200" y="274320"/>
+            <a:ext cx="10972800" cy="914400"/>
+          </a:xfrm>
+          <a:prstGeom prst="rect">
+            <a:avLst/>
+          </a:prstGeom>
+          <a:noFill/>
+        </p:spPr>
+        <p:txBody>
+          <a:bodyPr wrap="none">
+            <a:spAutoFit/>
+          </a:bodyPr>
+          <a:lstStyle/>
+          <a:p>
+            <a:pPr algn="l"/>
+          </a:p>
+          <a:p>
+            <a:pPr algn="l"/>
+            <a:r>
+              <a:rPr sz="4000" b="1">
+                <a:solidFill>
+                  <a:srgbClr val="16202E"/>
+                </a:solidFill>
+                <a:latin typeface="Montserrat"/>
+              </a:rPr>
+              <a:t>Operational Recovery Guide</a:t>
+            </a:r>
+          </a:p>
+        </p:txBody>
+      </p:sp>
+      <p:sp>
+        <p:nvSpPr>
+          <p:cNvPr id="3" name="Rectangle 2"/>
           <p:cNvSpPr/>
           <p:nvPr/>
         </p:nvSpPr>
         <p:spPr>
           <a:xfrm>
-            <a:off x="0" y="0"/>
-            <a:ext cx="12191695" cy="731520"/>
+            <a:off x="914400" y="1645920"/>
+            <a:ext cx="10332720" cy="4114800"/>
           </a:xfrm>
           <a:prstGeom prst="rect">
             <a:avLst/>
           </a:prstGeom>
           <a:solidFill>
-            <a:srgbClr val="161923"/>
+            <a:srgbClr val="16202E"/>
           </a:solidFill>
           <a:ln>
-            <a:noFill/>
+            <a:solidFill>
+              <a:srgbClr val="1A73E8"/>
+            </a:solidFill>
           </a:ln>
         </p:spPr>
         <p:style>
@@ -3927,168 +3947,108 @@
           <a:bodyPr rtlCol="0" anchor="ctr"/>
           <a:lstStyle/>
           <a:p>
-            <a:pPr algn="ctr"/>
-          </a:p>
-        </p:txBody>
-      </p:sp>
-      <p:sp>
-        <p:nvSpPr>
-          <p:cNvPr id="3" name="Rectangle 2"/>
-          <p:cNvSpPr/>
-          <p:nvPr/>
-        </p:nvSpPr>
-        <p:spPr>
-          <a:xfrm>
-            <a:off x="0" y="731520"/>
-            <a:ext cx="12191695" cy="45720"/>
-          </a:xfrm>
-          <a:prstGeom prst="rect">
-            <a:avLst/>
-          </a:prstGeom>
-          <a:solidFill>
-            <a:srgbClr val="20FC8F"/>
-          </a:solidFill>
-          <a:ln>
-            <a:noFill/>
-          </a:ln>
-        </p:spPr>
-        <p:style>
-          <a:lnRef idx="1">
-            <a:schemeClr val="accent1"/>
-          </a:lnRef>
-          <a:fillRef idx="3">
-            <a:schemeClr val="accent1"/>
-          </a:fillRef>
-          <a:effectRef idx="2">
-            <a:schemeClr val="accent1"/>
-          </a:effectRef>
-          <a:fontRef idx="minor">
-            <a:schemeClr val="lt1"/>
-          </a:fontRef>
-        </p:style>
-        <p:txBody>
-          <a:bodyPr rtlCol="0" anchor="ctr"/>
-          <a:lstStyle/>
-          <a:p>
-            <a:pPr algn="ctr"/>
-          </a:p>
-        </p:txBody>
-      </p:sp>
-      <p:sp>
-        <p:nvSpPr>
-          <p:cNvPr id="4" name="TextBox 3"/>
-          <p:cNvSpPr txBox="1"/>
-          <p:nvPr/>
-        </p:nvSpPr>
-        <p:spPr>
-          <a:xfrm>
-            <a:off x="457200" y="0"/>
-            <a:ext cx="11277295" cy="731520"/>
-          </a:xfrm>
-          <a:prstGeom prst="rect">
-            <a:avLst/>
-          </a:prstGeom>
-          <a:noFill/>
-        </p:spPr>
-        <p:txBody>
-          <a:bodyPr wrap="none">
-            <a:spAutoFit/>
-          </a:bodyPr>
-          <a:lstStyle/>
-          <a:p>
-            <a:pPr>
-              <a:defRPr sz="3600" b="1">
+            <a:pPr algn="l"/>
+            <a:r>
+              <a:rPr sz="2000" b="0">
                 <a:solidFill>
                   <a:srgbClr val="FFFFFF"/>
                 </a:solidFill>
-              </a:defRPr>
-            </a:pPr>
-            <a:r>
-              <a:t>Safety &amp; Governance</a:t>
-            </a:r>
-          </a:p>
-        </p:txBody>
-      </p:sp>
-      <p:sp>
-        <p:nvSpPr>
-          <p:cNvPr id="5" name="TextBox 4"/>
-          <p:cNvSpPr txBox="1"/>
-          <p:nvPr/>
-        </p:nvSpPr>
-        <p:spPr>
-          <a:xfrm>
-            <a:off x="914400" y="1371600"/>
-            <a:ext cx="10362895" cy="4572000"/>
-          </a:xfrm>
-          <a:prstGeom prst="rect">
-            <a:avLst/>
-          </a:prstGeom>
-          <a:noFill/>
-        </p:spPr>
-        <p:txBody>
-          <a:bodyPr wrap="none">
-            <a:spAutoFit/>
-          </a:bodyPr>
-          <a:lstStyle/>
-          <a:p/>
-          <a:p>
-            <a:pPr>
-              <a:spcAft>
-                <a:spcPts val="1500"/>
-              </a:spcAft>
-              <a:defRPr sz="2400">
-                <a:solidFill>
-                  <a:srgbClr val="102632"/>
-                </a:solidFill>
-              </a:defRPr>
-            </a:pPr>
-            <a:r>
-              <a:t>Org Admin Persistence: Cloud Infrastructure team retains access via Org-level IAM.</a:t>
-            </a:r>
-          </a:p>
-          <a:p>
-            <a:pPr>
-              <a:spcAft>
-                <a:spcPts val="1500"/>
-              </a:spcAft>
-              <a:defRPr sz="2400">
-                <a:solidFill>
-                  <a:srgbClr val="102632"/>
-                </a:solidFill>
-              </a:defRPr>
-            </a:pPr>
-            <a:r>
-              <a:t>Automated Rollback: One-command restoration of full access policies from GCS backups.</a:t>
-            </a:r>
-          </a:p>
-          <a:p>
-            <a:pPr>
-              <a:spcAft>
-                <a:spcPts val="1500"/>
-              </a:spcAft>
-              <a:defRPr sz="2400">
-                <a:solidFill>
-                  <a:srgbClr val="102632"/>
-                </a:solidFill>
-              </a:defRPr>
-            </a:pPr>
-            <a:r>
-              <a:t>Time Travel Window: 7-day post-deletion window for emergency table recovery.</a:t>
-            </a:r>
-          </a:p>
-          <a:p>
-            <a:pPr>
-              <a:spcAft>
-                <a:spcPts val="1500"/>
-              </a:spcAft>
-              <a:defRPr sz="2400">
-                <a:solidFill>
-                  <a:srgbClr val="102632"/>
-                </a:solidFill>
-              </a:defRPr>
-            </a:pPr>
-            <a:r>
-              <a:t>Dry-Run Mode: Mandatory simulation phase for every tranche before execution.</a:t>
+                <a:latin typeface="Courier New"/>
+              </a:rPr>
+              <a:t># Restore a specific dataset</a:t>
+            </a:r>
+          </a:p>
+          <a:p>
+            <a:pPr algn="l"/>
+            <a:r>
+              <a:rPr sz="2000" b="0">
+                <a:solidFill>
+                  <a:srgbClr val="FFFFFF"/>
+                </a:solidFill>
+                <a:latin typeface="Courier New"/>
+              </a:rPr>
+              <a:t>python3 bq_restore_access.py --dataset project:dataset</a:t>
+            </a:r>
+          </a:p>
+          <a:p>
+            <a:pPr algn="l"/>
+          </a:p>
+          <a:p>
+            <a:pPr algn="l"/>
+            <a:r>
+              <a:rPr sz="2000" b="0">
+                <a:solidFill>
+                  <a:srgbClr val="FFFFFF"/>
+                </a:solidFill>
+                <a:latin typeface="Courier New"/>
+              </a:rPr>
+              <a:t># Restore an entire tranche (e.g., if a whole team 'screams')</a:t>
+            </a:r>
+          </a:p>
+          <a:p>
+            <a:pPr algn="l"/>
+            <a:r>
+              <a:rPr sz="2000" b="0">
+                <a:solidFill>
+                  <a:srgbClr val="FFFFFF"/>
+                </a:solidFill>
+                <a:latin typeface="Courier New"/>
+              </a:rPr>
+              <a:t>python3 bq_restore_access.py --tranche 1.1</a:t>
+            </a:r>
+          </a:p>
+          <a:p>
+            <a:pPr algn="l"/>
+          </a:p>
+          <a:p>
+            <a:pPr algn="l"/>
+            <a:r>
+              <a:rPr sz="2000" b="0">
+                <a:solidFill>
+                  <a:srgbClr val="FFFFFF"/>
+                </a:solidFill>
+                <a:latin typeface="Courier New"/>
+              </a:rPr>
+              <a:t># Emergency 'Undo' for all active scream tests</a:t>
+            </a:r>
+          </a:p>
+          <a:p>
+            <a:pPr algn="l"/>
+            <a:r>
+              <a:rPr sz="2000" b="0">
+                <a:solidFill>
+                  <a:srgbClr val="FFFFFF"/>
+                </a:solidFill>
+                <a:latin typeface="Courier New"/>
+              </a:rPr>
+              <a:t>python3 bq_restore_access.py --all</a:t>
+            </a:r>
+          </a:p>
+          <a:p>
+            <a:pPr algn="l"/>
+          </a:p>
+          <a:p>
+            <a:pPr algn="l"/>
+            <a:r>
+              <a:rPr sz="2000" b="0">
+                <a:solidFill>
+                  <a:srgbClr val="FFFFFF"/>
+                </a:solidFill>
+                <a:latin typeface="Courier New"/>
+              </a:rPr>
+              <a:t># Verify backup presence before restoration</a:t>
+            </a:r>
+          </a:p>
+          <a:p>
+            <a:pPr algn="l"/>
+            <a:r>
+              <a:rPr sz="2000" b="0">
+                <a:solidFill>
+                  <a:srgbClr val="FFFFFF"/>
+                </a:solidFill>
+                <a:latin typeface="Courier New"/>
+              </a:rPr>
+              <a:t>gsutil ls gs://bq-admin-backup/backups/</a:t>
             </a:r>
           </a:p>
         </p:txBody>
@@ -4113,100 +4073,14 @@
       <p:grpSpPr/>
       <p:sp>
         <p:nvSpPr>
-          <p:cNvPr id="2" name="Rectangle 1"/>
-          <p:cNvSpPr/>
+          <p:cNvPr id="2" name="TextBox 1"/>
+          <p:cNvSpPr txBox="1"/>
           <p:nvPr/>
         </p:nvSpPr>
         <p:spPr>
           <a:xfrm>
-            <a:off x="0" y="0"/>
-            <a:ext cx="12191695" cy="731520"/>
-          </a:xfrm>
-          <a:prstGeom prst="rect">
-            <a:avLst/>
-          </a:prstGeom>
-          <a:solidFill>
-            <a:srgbClr val="161923"/>
-          </a:solidFill>
-          <a:ln>
-            <a:noFill/>
-          </a:ln>
-        </p:spPr>
-        <p:style>
-          <a:lnRef idx="1">
-            <a:schemeClr val="accent1"/>
-          </a:lnRef>
-          <a:fillRef idx="3">
-            <a:schemeClr val="accent1"/>
-          </a:fillRef>
-          <a:effectRef idx="2">
-            <a:schemeClr val="accent1"/>
-          </a:effectRef>
-          <a:fontRef idx="minor">
-            <a:schemeClr val="lt1"/>
-          </a:fontRef>
-        </p:style>
-        <p:txBody>
-          <a:bodyPr rtlCol="0" anchor="ctr"/>
-          <a:lstStyle/>
-          <a:p>
-            <a:pPr algn="ctr"/>
-          </a:p>
-        </p:txBody>
-      </p:sp>
-      <p:sp>
-        <p:nvSpPr>
-          <p:cNvPr id="3" name="Rectangle 2"/>
-          <p:cNvSpPr/>
-          <p:nvPr/>
-        </p:nvSpPr>
-        <p:spPr>
-          <a:xfrm>
-            <a:off x="0" y="731520"/>
-            <a:ext cx="12191695" cy="45720"/>
-          </a:xfrm>
-          <a:prstGeom prst="rect">
-            <a:avLst/>
-          </a:prstGeom>
-          <a:solidFill>
-            <a:srgbClr val="20FC8F"/>
-          </a:solidFill>
-          <a:ln>
-            <a:noFill/>
-          </a:ln>
-        </p:spPr>
-        <p:style>
-          <a:lnRef idx="1">
-            <a:schemeClr val="accent1"/>
-          </a:lnRef>
-          <a:fillRef idx="3">
-            <a:schemeClr val="accent1"/>
-          </a:fillRef>
-          <a:effectRef idx="2">
-            <a:schemeClr val="accent1"/>
-          </a:effectRef>
-          <a:fontRef idx="minor">
-            <a:schemeClr val="lt1"/>
-          </a:fontRef>
-        </p:style>
-        <p:txBody>
-          <a:bodyPr rtlCol="0" anchor="ctr"/>
-          <a:lstStyle/>
-          <a:p>
-            <a:pPr algn="ctr"/>
-          </a:p>
-        </p:txBody>
-      </p:sp>
-      <p:sp>
-        <p:nvSpPr>
-          <p:cNvPr id="4" name="TextBox 3"/>
-          <p:cNvSpPr txBox="1"/>
-          <p:nvPr/>
-        </p:nvSpPr>
-        <p:spPr>
-          <a:xfrm>
-            <a:off x="457200" y="0"/>
-            <a:ext cx="11277295" cy="731520"/>
+            <a:off x="457200" y="274320"/>
+            <a:ext cx="10972800" cy="914400"/>
           </a:xfrm>
           <a:prstGeom prst="rect">
             <a:avLst/>
@@ -4219,305 +4093,84 @@
           </a:bodyPr>
           <a:lstStyle/>
           <a:p>
-            <a:pPr>
-              <a:defRPr sz="3600" b="1">
-                <a:solidFill>
-                  <a:srgbClr val="FFFFFF"/>
-                </a:solidFill>
-              </a:defRPr>
-            </a:pPr>
-            <a:r>
-              <a:t>Current Status: Tranche Overview</a:t>
-            </a:r>
-          </a:p>
-        </p:txBody>
-      </p:sp>
-      <p:graphicFrame>
-        <p:nvGraphicFramePr>
-          <p:cNvPr id="5" name="Table 4"/>
-          <p:cNvGraphicFramePr>
-            <a:graphicFrameLocks noGrp="1"/>
-          </p:cNvGraphicFramePr>
+            <a:pPr algn="l"/>
+          </a:p>
+          <a:p>
+            <a:pPr algn="l"/>
+            <a:r>
+              <a:rPr sz="4000" b="1">
+                <a:solidFill>
+                  <a:srgbClr val="16202E"/>
+                </a:solidFill>
+                <a:latin typeface="Montserrat"/>
+              </a:rPr>
+              <a:t>A clear view of the numbers</a:t>
+            </a:r>
+          </a:p>
+        </p:txBody>
+      </p:sp>
+      <p:sp>
+        <p:nvSpPr>
+          <p:cNvPr id="3" name="TextBox 2"/>
+          <p:cNvSpPr txBox="1"/>
           <p:nvPr/>
-        </p:nvGraphicFramePr>
-        <p:xfrm>
-          <a:off x="914400" y="1828800"/>
-          <a:ext cx="10058400" cy="3657600"/>
-        </p:xfrm>
-        <a:graphic>
-          <a:graphicData uri="http://schemas.openxmlformats.org/drawingml/2006/table">
-            <a:tbl>
-              <a:tblPr firstRow="1" bandRow="1">
-                <a:tableStyleId>{5C22544A-7EE6-4342-B048-85BDC9FD1C3A}</a:tableStyleId>
-              </a:tblPr>
-              <a:tblGrid>
-                <a:gridCol w="3352800"/>
-                <a:gridCol w="3352800"/>
-                <a:gridCol w="3352800"/>
-              </a:tblGrid>
-              <a:tr h="731520">
-                <a:tc>
-                  <a:txBody>
-                    <a:bodyPr/>
-                    <a:lstStyle/>
-                    <a:p>
-                      <a:pPr>
-                        <a:defRPr b="1">
-                          <a:solidFill>
-                            <a:srgbClr val="20FC8F"/>
-                          </a:solidFill>
-                        </a:defRPr>
-                      </a:pPr>
-                      <a:r>
-                        <a:t>Tranche</a:t>
-                      </a:r>
-                    </a:p>
-                  </a:txBody>
-                  <a:tcPr>
-                    <a:solidFill>
-                      <a:srgbClr val="161923"/>
-                    </a:solidFill>
-                  </a:tcPr>
-                </a:tc>
-                <a:tc>
-                  <a:txBody>
-                    <a:bodyPr/>
-                    <a:lstStyle/>
-                    <a:p>
-                      <a:pPr>
-                        <a:defRPr b="1">
-                          <a:solidFill>
-                            <a:srgbClr val="20FC8F"/>
-                          </a:solidFill>
-                        </a:defRPr>
-                      </a:pPr>
-                      <a:r>
-                        <a:t>Target Profile</a:t>
-                      </a:r>
-                    </a:p>
-                  </a:txBody>
-                  <a:tcPr>
-                    <a:solidFill>
-                      <a:srgbClr val="161923"/>
-                    </a:solidFill>
-                  </a:tcPr>
-                </a:tc>
-                <a:tc>
-                  <a:txBody>
-                    <a:bodyPr/>
-                    <a:lstStyle/>
-                    <a:p>
-                      <a:pPr>
-                        <a:defRPr b="1">
-                          <a:solidFill>
-                            <a:srgbClr val="20FC8F"/>
-                          </a:solidFill>
-                        </a:defRPr>
-                      </a:pPr>
-                      <a:r>
-                        <a:t>Status</a:t>
-                      </a:r>
-                    </a:p>
-                  </a:txBody>
-                  <a:tcPr>
-                    <a:solidFill>
-                      <a:srgbClr val="161923"/>
-                    </a:solidFill>
-                  </a:tcPr>
-                </a:tc>
-              </a:tr>
-              <a:tr h="731520">
-                <a:tc>
-                  <a:txBody>
-                    <a:bodyPr/>
-                    <a:lstStyle/>
-                    <a:p>
-                      <a:pPr>
-                        <a:defRPr sz="2000"/>
-                      </a:pPr>
-                      <a:r>
-                        <a:t>Tranche 1</a:t>
-                      </a:r>
-                    </a:p>
-                  </a:txBody>
-                  <a:tcPr/>
-                </a:tc>
-                <a:tc>
-                  <a:txBody>
-                    <a:bodyPr/>
-                    <a:lstStyle/>
-                    <a:p>
-                      <a:pPr>
-                        <a:defRPr sz="2000"/>
-                      </a:pPr>
-                      <a:r>
-                        <a:t>Abandoned Test/Temp (&gt;1yr)</a:t>
-                      </a:r>
-                    </a:p>
-                  </a:txBody>
-                  <a:tcPr/>
-                </a:tc>
-                <a:tc>
-                  <a:txBody>
-                    <a:bodyPr/>
-                    <a:lstStyle/>
-                    <a:p>
-                      <a:pPr>
-                        <a:defRPr sz="2000"/>
-                      </a:pPr>
-                      <a:r>
-                        <a:t>COMPLETE</a:t>
-                      </a:r>
-                    </a:p>
-                  </a:txBody>
-                  <a:tcPr/>
-                </a:tc>
-              </a:tr>
-              <a:tr h="731520">
-                <a:tc>
-                  <a:txBody>
-                    <a:bodyPr/>
-                    <a:lstStyle/>
-                    <a:p>
-                      <a:pPr>
-                        <a:defRPr sz="2000"/>
-                      </a:pPr>
-                      <a:r>
-                        <a:t>Tranche 1.1</a:t>
-                      </a:r>
-                    </a:p>
-                  </a:txBody>
-                  <a:tcPr/>
-                </a:tc>
-                <a:tc>
-                  <a:txBody>
-                    <a:bodyPr/>
-                    <a:lstStyle/>
-                    <a:p>
-                      <a:pPr>
-                        <a:defRPr sz="2000"/>
-                      </a:pPr>
-                      <a:r>
-                        <a:t>Refined Test Targets</a:t>
-                      </a:r>
-                    </a:p>
-                  </a:txBody>
-                  <a:tcPr/>
-                </a:tc>
-                <a:tc>
-                  <a:txBody>
-                    <a:bodyPr/>
-                    <a:lstStyle/>
-                    <a:p>
-                      <a:pPr>
-                        <a:defRPr sz="2000"/>
-                      </a:pPr>
-                      <a:r>
-                        <a:t>IN PROGRESS</a:t>
-                      </a:r>
-                    </a:p>
-                  </a:txBody>
-                  <a:tcPr/>
-                </a:tc>
-              </a:tr>
-              <a:tr h="731520">
-                <a:tc>
-                  <a:txBody>
-                    <a:bodyPr/>
-                    <a:lstStyle/>
-                    <a:p>
-                      <a:pPr>
-                        <a:defRPr sz="2000"/>
-                      </a:pPr>
-                      <a:r>
-                        <a:t>Tranche 2</a:t>
-                      </a:r>
-                    </a:p>
-                  </a:txBody>
-                  <a:tcPr/>
-                </a:tc>
-                <a:tc>
-                  <a:txBody>
-                    <a:bodyPr/>
-                    <a:lstStyle/>
-                    <a:p>
-                      <a:pPr>
-                        <a:defRPr sz="2000"/>
-                      </a:pPr>
-                      <a:r>
-                        <a:t>Large Prod (&gt;100GB, Stale)</a:t>
-                      </a:r>
-                    </a:p>
-                  </a:txBody>
-                  <a:tcPr/>
-                </a:tc>
-                <a:tc>
-                  <a:txBody>
-                    <a:bodyPr/>
-                    <a:lstStyle/>
-                    <a:p>
-                      <a:pPr>
-                        <a:defRPr sz="2000"/>
-                      </a:pPr>
-                      <a:r>
-                        <a:t>CONFIRMED</a:t>
-                      </a:r>
-                    </a:p>
-                  </a:txBody>
-                  <a:tcPr/>
-                </a:tc>
-              </a:tr>
-              <a:tr h="731520">
-                <a:tc>
-                  <a:txBody>
-                    <a:bodyPr/>
-                    <a:lstStyle/>
-                    <a:p>
-                      <a:pPr>
-                        <a:defRPr sz="2000"/>
-                      </a:pPr>
-                      <a:r>
-                        <a:t>Tranche 3</a:t>
-                      </a:r>
-                    </a:p>
-                  </a:txBody>
-                  <a:tcPr/>
-                </a:tc>
-                <a:tc>
-                  <a:txBody>
-                    <a:bodyPr/>
-                    <a:lstStyle/>
-                    <a:p>
-                      <a:pPr>
-                        <a:defRPr sz="2000"/>
-                      </a:pPr>
-                      <a:r>
-                        <a:t>Small Prod Stale</a:t>
-                      </a:r>
-                    </a:p>
-                  </a:txBody>
-                  <a:tcPr/>
-                </a:tc>
-                <a:tc>
-                  <a:txBody>
-                    <a:bodyPr/>
-                    <a:lstStyle/>
-                    <a:p>
-                      <a:pPr>
-                        <a:defRPr sz="2000"/>
-                      </a:pPr>
-                      <a:r>
-                        <a:t>REVIEW</a:t>
-                      </a:r>
-                    </a:p>
-                  </a:txBody>
-                  <a:tcPr/>
-                </a:tc>
-              </a:tr>
-            </a:tbl>
-          </a:graphicData>
-        </a:graphic>
-      </p:graphicFrame>
+        </p:nvSpPr>
+        <p:spPr>
+          <a:xfrm>
+            <a:off x="457200" y="1828800"/>
+            <a:ext cx="10972800" cy="2743200"/>
+          </a:xfrm>
+          <a:prstGeom prst="rect">
+            <a:avLst/>
+          </a:prstGeom>
+          <a:noFill/>
+        </p:spPr>
+        <p:txBody>
+          <a:bodyPr wrap="none">
+            <a:spAutoFit/>
+          </a:bodyPr>
+          <a:lstStyle/>
+          <a:p>
+            <a:pPr algn="l"/>
+          </a:p>
+          <a:p>
+            <a:pPr algn="l"/>
+            <a:r>
+              <a:rPr sz="3200" b="0">
+                <a:solidFill>
+                  <a:srgbClr val="16202E"/>
+                </a:solidFill>
+                <a:latin typeface="Open Sans"/>
+              </a:rPr>
+              <a:t>Audit complete across 50+ projects.</a:t>
+            </a:r>
+          </a:p>
+          <a:p>
+            <a:pPr algn="l"/>
+            <a:r>
+              <a:rPr sz="3200" b="0">
+                <a:solidFill>
+                  <a:srgbClr val="16202E"/>
+                </a:solidFill>
+                <a:latin typeface="Open Sans"/>
+              </a:rPr>
+              <a:t>Tranche 1 (Abandoned) targets: 120+ datasets.</a:t>
+            </a:r>
+          </a:p>
+          <a:p>
+            <a:pPr algn="l"/>
+            <a:r>
+              <a:rPr sz="3200" b="0">
+                <a:solidFill>
+                  <a:srgbClr val="16202E"/>
+                </a:solidFill>
+                <a:latin typeface="Open Sans"/>
+              </a:rPr>
+              <a:t>Estimated annual savings: $42,000+ (Storage only).</a:t>
+            </a:r>
+          </a:p>
+        </p:txBody>
+      </p:sp>
     </p:spTree>
   </p:cSld>
   <p:clrMapOvr>

</xml_diff>

<commit_message>
docs: refine savings metrics and add repo URL to presentation
</commit_message>
<xml_diff>
--- a/BigQuery_Housekeeping_Process.pptx
+++ b/BigQuery_Housekeeping_Process.pptx
@@ -4104,7 +4104,7 @@
                 </a:solidFill>
                 <a:latin typeface="Montserrat"/>
               </a:rPr>
-              <a:t>A clear view of the numbers</a:t>
+              <a:t>Targeted Savings &amp; Repository</a:t>
             </a:r>
           </a:p>
         </p:txBody>
@@ -4118,7 +4118,7 @@
         <p:spPr>
           <a:xfrm>
             <a:off x="457200" y="1828800"/>
-            <a:ext cx="10972800" cy="2743200"/>
+            <a:ext cx="10972800" cy="3200400"/>
           </a:xfrm>
           <a:prstGeom prst="rect">
             <a:avLst/>
@@ -4154,7 +4154,7 @@
                 </a:solidFill>
                 <a:latin typeface="Open Sans"/>
               </a:rPr>
-              <a:t>Tranche 1 (Abandoned) targets: 120+ datasets.</a:t>
+              <a:t>Identified 120+ Stale/Abandoned datasets (Tranche 1-3).</a:t>
             </a:r>
           </a:p>
           <a:p>
@@ -4166,7 +4166,32 @@
                 </a:solidFill>
                 <a:latin typeface="Open Sans"/>
               </a:rPr>
-              <a:t>Estimated annual savings: $42,000+ (Storage only).</a:t>
+              <a:t>Estimated annual savings: $28,400+ (Stale Data Storage Only).</a:t>
+            </a:r>
+          </a:p>
+          <a:p>
+            <a:br/>
+            <a:pPr algn="l"/>
+            <a:r>
+              <a:rPr sz="2400" b="1">
+                <a:solidFill>
+                  <a:srgbClr val="1A73E8"/>
+                </a:solidFill>
+                <a:latin typeface="Open Sans"/>
+              </a:rPr>
+              <a:t>Code &amp; Documentation Repository:</a:t>
+            </a:r>
+          </a:p>
+          <a:p>
+            <a:pPr algn="l"/>
+            <a:r>
+              <a:rPr sz="3200" b="0">
+                <a:solidFill>
+                  <a:srgbClr val="16202E"/>
+                </a:solidFill>
+                <a:latin typeface="Open Sans"/>
+              </a:rPr>
+              <a:t>https://github.com/alandoddthg/bq-housekeeping</a:t>
             </a:r>
           </a:p>
         </p:txBody>

</xml_diff>

<commit_message>
feat: include audit control file and expand presentation with tranche details
</commit_message>
<xml_diff>
--- a/BigQuery_Housekeeping_Process.pptx
+++ b/BigQuery_Housekeeping_Process.pptx
@@ -3257,7 +3257,7 @@
                 </a:solidFill>
                 <a:latin typeface="Montserrat"/>
               </a:rPr>
-              <a:t>Where we stand</a:t>
+              <a:t>How to recover (Emergency Protocol)</a:t>
             </a:r>
           </a:p>
         </p:txBody>
@@ -3270,8 +3270,8 @@
         </p:nvSpPr>
         <p:spPr>
           <a:xfrm>
-            <a:off x="457200" y="1097280"/>
-            <a:ext cx="10972800" cy="914400"/>
+            <a:off x="457200" y="1645920"/>
+            <a:ext cx="10972800" cy="457200"/>
           </a:xfrm>
           <a:prstGeom prst="rect">
             <a:avLst/>
@@ -3289,13 +3289,13 @@
           <a:p>
             <a:pPr algn="l"/>
             <a:r>
-              <a:rPr sz="2200" b="0">
+              <a:rPr sz="2400" b="1">
                 <a:solidFill>
-                  <a:srgbClr val="16202E"/>
+                  <a:srgbClr val="1A73E8"/>
                 </a:solidFill>
-                <a:latin typeface="Open Sans"/>
+                <a:latin typeface="Montserrat"/>
               </a:rPr>
-              <a:t>A multi-stage process to eliminate 'Zombie Data' with zero risk to production operations.</a:t>
+              <a:t>1. Automated Restore</a:t>
             </a:r>
           </a:p>
         </p:txBody>
@@ -3308,8 +3308,8 @@
         </p:nvSpPr>
         <p:spPr>
           <a:xfrm>
-            <a:off x="457200" y="2286000"/>
-            <a:ext cx="3657600" cy="914400"/>
+            <a:off x="457200" y="2011680"/>
+            <a:ext cx="10972800" cy="731520"/>
           </a:xfrm>
           <a:prstGeom prst="rect">
             <a:avLst/>
@@ -3327,13 +3327,13 @@
           <a:p>
             <a:pPr algn="l"/>
             <a:r>
-              <a:rPr sz="4400" b="1">
+              <a:rPr sz="1800" b="0">
                 <a:solidFill>
-                  <a:srgbClr val="5A6675"/>
+                  <a:srgbClr val="16202E"/>
                 </a:solidFill>
-                <a:latin typeface="Montserrat"/>
+                <a:latin typeface="Open Sans"/>
               </a:rPr>
-              <a:t>Audit</a:t>
+              <a:t>Use `bq_restore_access.py` to pull metadata from `gs://bq-admin-backup/` and reapply in seconds.</a:t>
             </a:r>
           </a:p>
         </p:txBody>
@@ -3347,7 +3347,7 @@
         <p:spPr>
           <a:xfrm>
             <a:off x="457200" y="3017520"/>
-            <a:ext cx="3657600" cy="457200"/>
+            <a:ext cx="10972800" cy="457200"/>
           </a:xfrm>
           <a:prstGeom prst="rect">
             <a:avLst/>
@@ -3365,27 +3365,65 @@
           <a:p>
             <a:pPr algn="l"/>
             <a:r>
+              <a:rPr sz="2400" b="1">
+                <a:solidFill>
+                  <a:srgbClr val="1A73E8"/>
+                </a:solidFill>
+                <a:latin typeface="Montserrat"/>
+              </a:rPr>
+              <a:t>2. Metadata Integrity</a:t>
+            </a:r>
+          </a:p>
+        </p:txBody>
+      </p:sp>
+      <p:sp>
+        <p:nvSpPr>
+          <p:cNvPr id="6" name="TextBox 5"/>
+          <p:cNvSpPr txBox="1"/>
+          <p:nvPr/>
+        </p:nvSpPr>
+        <p:spPr>
+          <a:xfrm>
+            <a:off x="457200" y="3383280"/>
+            <a:ext cx="10972800" cy="731520"/>
+          </a:xfrm>
+          <a:prstGeom prst="rect">
+            <a:avLst/>
+          </a:prstGeom>
+          <a:noFill/>
+        </p:spPr>
+        <p:txBody>
+          <a:bodyPr wrap="none">
+            <a:spAutoFit/>
+          </a:bodyPr>
+          <a:lstStyle/>
+          <a:p>
+            <a:pPr algn="l"/>
+          </a:p>
+          <a:p>
+            <a:pPr algn="l"/>
+            <a:r>
               <a:rPr sz="1800" b="0">
                 <a:solidFill>
                   <a:srgbClr val="16202E"/>
                 </a:solidFill>
                 <a:latin typeface="Open Sans"/>
               </a:rPr>
-              <a:t>Deep history scan (180d+)</a:t>
-            </a:r>
-          </a:p>
-        </p:txBody>
-      </p:sp>
-      <p:sp>
-        <p:nvSpPr>
-          <p:cNvPr id="6" name="TextBox 5"/>
+              <a:t>Full access policies are versioned to GCS *before* any modification.</a:t>
+            </a:r>
+          </a:p>
+        </p:txBody>
+      </p:sp>
+      <p:sp>
+        <p:nvSpPr>
+          <p:cNvPr id="7" name="TextBox 6"/>
           <p:cNvSpPr txBox="1"/>
           <p:nvPr/>
         </p:nvSpPr>
         <p:spPr>
           <a:xfrm>
-            <a:off x="4389120" y="2286000"/>
-            <a:ext cx="3657600" cy="914400"/>
+            <a:off x="457200" y="4389120"/>
+            <a:ext cx="10972800" cy="457200"/>
           </a:xfrm>
           <a:prstGeom prst="rect">
             <a:avLst/>
@@ -3403,27 +3441,27 @@
           <a:p>
             <a:pPr algn="l"/>
             <a:r>
-              <a:rPr sz="4400" b="1">
+              <a:rPr sz="2400" b="1">
                 <a:solidFill>
                   <a:srgbClr val="1A73E8"/>
                 </a:solidFill>
                 <a:latin typeface="Montserrat"/>
               </a:rPr>
-              <a:t>Scream Test</a:t>
-            </a:r>
-          </a:p>
-        </p:txBody>
-      </p:sp>
-      <p:sp>
-        <p:nvSpPr>
-          <p:cNvPr id="7" name="TextBox 6"/>
+              <a:t>3. Org-Level Access</a:t>
+            </a:r>
+          </a:p>
+        </p:txBody>
+      </p:sp>
+      <p:sp>
+        <p:nvSpPr>
+          <p:cNvPr id="8" name="TextBox 7"/>
           <p:cNvSpPr txBox="1"/>
           <p:nvPr/>
         </p:nvSpPr>
         <p:spPr>
           <a:xfrm>
-            <a:off x="4389120" y="3017520"/>
-            <a:ext cx="3657600" cy="457200"/>
+            <a:off x="457200" y="4754880"/>
+            <a:ext cx="10972800" cy="731520"/>
           </a:xfrm>
           <a:prstGeom prst="rect">
             <a:avLst/>
@@ -3447,83 +3485,7 @@
                 </a:solidFill>
                 <a:latin typeface="Open Sans"/>
               </a:rPr>
-              <a:t>Access revocation monitoring</a:t>
-            </a:r>
-          </a:p>
-        </p:txBody>
-      </p:sp>
-      <p:sp>
-        <p:nvSpPr>
-          <p:cNvPr id="8" name="TextBox 7"/>
-          <p:cNvSpPr txBox="1"/>
-          <p:nvPr/>
-        </p:nvSpPr>
-        <p:spPr>
-          <a:xfrm>
-            <a:off x="8321040" y="2286000"/>
-            <a:ext cx="3657600" cy="914400"/>
-          </a:xfrm>
-          <a:prstGeom prst="rect">
-            <a:avLst/>
-          </a:prstGeom>
-          <a:noFill/>
-        </p:spPr>
-        <p:txBody>
-          <a:bodyPr wrap="none">
-            <a:spAutoFit/>
-          </a:bodyPr>
-          <a:lstStyle/>
-          <a:p>
-            <a:pPr algn="l"/>
-          </a:p>
-          <a:p>
-            <a:pPr algn="l"/>
-            <a:r>
-              <a:rPr sz="4400" b="1">
-                <a:solidFill>
-                  <a:srgbClr val="1E8E5A"/>
-                </a:solidFill>
-                <a:latin typeface="Montserrat"/>
-              </a:rPr>
-              <a:t>Recoverable</a:t>
-            </a:r>
-          </a:p>
-        </p:txBody>
-      </p:sp>
-      <p:sp>
-        <p:nvSpPr>
-          <p:cNvPr id="9" name="TextBox 8"/>
-          <p:cNvSpPr txBox="1"/>
-          <p:nvPr/>
-        </p:nvSpPr>
-        <p:spPr>
-          <a:xfrm>
-            <a:off x="8321040" y="3017520"/>
-            <a:ext cx="3657600" cy="457200"/>
-          </a:xfrm>
-          <a:prstGeom prst="rect">
-            <a:avLst/>
-          </a:prstGeom>
-          <a:noFill/>
-        </p:spPr>
-        <p:txBody>
-          <a:bodyPr wrap="none">
-            <a:spAutoFit/>
-          </a:bodyPr>
-          <a:lstStyle/>
-          <a:p>
-            <a:pPr algn="l"/>
-          </a:p>
-          <a:p>
-            <a:pPr algn="l"/>
-            <a:r>
-              <a:rPr sz="1800" b="0">
-                <a:solidFill>
-                  <a:srgbClr val="16202E"/>
-                </a:solidFill>
-                <a:latin typeface="Open Sans"/>
-              </a:rPr>
-              <a:t>7-day post-deletion window</a:t>
+              <a:t>Org Admins retain management persistence via Org-level IAM; zero lockout risk.</a:t>
             </a:r>
           </a:p>
         </p:txBody>
@@ -3579,277 +3541,700 @@
                 </a:solidFill>
                 <a:latin typeface="Montserrat"/>
               </a:rPr>
-              <a:t>How to recover (Emergency Protocol)</a:t>
-            </a:r>
-          </a:p>
-        </p:txBody>
-      </p:sp>
-      <p:sp>
-        <p:nvSpPr>
-          <p:cNvPr id="3" name="TextBox 2"/>
-          <p:cNvSpPr txBox="1"/>
+              <a:t>Tranche Analysis: Stale &amp; Abandoned Data</a:t>
+            </a:r>
+          </a:p>
+        </p:txBody>
+      </p:sp>
+      <p:graphicFrame>
+        <p:nvGraphicFramePr>
+          <p:cNvPr id="3" name="Table 2"/>
+          <p:cNvGraphicFramePr>
+            <a:graphicFrameLocks noGrp="1"/>
+          </p:cNvGraphicFramePr>
           <p:nvPr/>
-        </p:nvSpPr>
-        <p:spPr>
-          <a:xfrm>
-            <a:off x="457200" y="1097280"/>
-            <a:ext cx="10972800" cy="914400"/>
-          </a:xfrm>
-          <a:prstGeom prst="rect">
-            <a:avLst/>
-          </a:prstGeom>
-          <a:noFill/>
-        </p:spPr>
-        <p:txBody>
-          <a:bodyPr wrap="none">
-            <a:spAutoFit/>
-          </a:bodyPr>
-          <a:lstStyle/>
-          <a:p>
-            <a:pPr algn="l"/>
-          </a:p>
-          <a:p>
-            <a:pPr algn="l"/>
-            <a:r>
-              <a:rPr sz="2200" b="0">
-                <a:solidFill>
-                  <a:srgbClr val="5A6675"/>
-                </a:solidFill>
-                <a:latin typeface="Open Sans"/>
-              </a:rPr>
-              <a:t>In the event of a 'Scream', access can be restored to any dataset in seconds.</a:t>
-            </a:r>
-          </a:p>
-        </p:txBody>
-      </p:sp>
-      <p:sp>
-        <p:nvSpPr>
-          <p:cNvPr id="4" name="TextBox 3"/>
-          <p:cNvSpPr txBox="1"/>
-          <p:nvPr/>
-        </p:nvSpPr>
-        <p:spPr>
-          <a:xfrm>
-            <a:off x="457200" y="2286000"/>
-            <a:ext cx="10972800" cy="457200"/>
-          </a:xfrm>
-          <a:prstGeom prst="rect">
-            <a:avLst/>
-          </a:prstGeom>
-          <a:noFill/>
-        </p:spPr>
-        <p:txBody>
-          <a:bodyPr wrap="none">
-            <a:spAutoFit/>
-          </a:bodyPr>
-          <a:lstStyle/>
-          <a:p>
-            <a:pPr algn="l"/>
-          </a:p>
-          <a:p>
-            <a:pPr algn="l"/>
-            <a:r>
-              <a:rPr sz="2400" b="1">
-                <a:solidFill>
-                  <a:srgbClr val="1A73E8"/>
-                </a:solidFill>
-                <a:latin typeface="Montserrat"/>
-              </a:rPr>
-              <a:t>1. Automated Restore</a:t>
-            </a:r>
-          </a:p>
-        </p:txBody>
-      </p:sp>
-      <p:sp>
-        <p:nvSpPr>
-          <p:cNvPr id="5" name="TextBox 4"/>
-          <p:cNvSpPr txBox="1"/>
-          <p:nvPr/>
-        </p:nvSpPr>
-        <p:spPr>
-          <a:xfrm>
-            <a:off x="457200" y="2651760"/>
-            <a:ext cx="10972800" cy="731520"/>
-          </a:xfrm>
-          <a:prstGeom prst="rect">
-            <a:avLst/>
-          </a:prstGeom>
-          <a:noFill/>
-        </p:spPr>
-        <p:txBody>
-          <a:bodyPr wrap="none">
-            <a:spAutoFit/>
-          </a:bodyPr>
-          <a:lstStyle/>
-          <a:p>
-            <a:pPr algn="l"/>
-          </a:p>
-          <a:p>
-            <a:pPr algn="l"/>
-            <a:r>
-              <a:rPr sz="1800" b="0">
-                <a:solidFill>
-                  <a:srgbClr val="16202E"/>
-                </a:solidFill>
-                <a:latin typeface="Open Sans"/>
-              </a:rPr>
-              <a:t>Use the `bq_restore_access.py` tool. It automatically pulls the metadata backup from GCS and reapplies it.</a:t>
-            </a:r>
-          </a:p>
-        </p:txBody>
-      </p:sp>
-      <p:sp>
-        <p:nvSpPr>
-          <p:cNvPr id="6" name="TextBox 5"/>
-          <p:cNvSpPr txBox="1"/>
-          <p:nvPr/>
-        </p:nvSpPr>
-        <p:spPr>
-          <a:xfrm>
-            <a:off x="457200" y="3657600"/>
-            <a:ext cx="10972800" cy="457200"/>
-          </a:xfrm>
-          <a:prstGeom prst="rect">
-            <a:avLst/>
-          </a:prstGeom>
-          <a:noFill/>
-        </p:spPr>
-        <p:txBody>
-          <a:bodyPr wrap="none">
-            <a:spAutoFit/>
-          </a:bodyPr>
-          <a:lstStyle/>
-          <a:p>
-            <a:pPr algn="l"/>
-          </a:p>
-          <a:p>
-            <a:pPr algn="l"/>
-            <a:r>
-              <a:rPr sz="2400" b="1">
-                <a:solidFill>
-                  <a:srgbClr val="1A73E8"/>
-                </a:solidFill>
-                <a:latin typeface="Montserrat"/>
-              </a:rPr>
-              <a:t>2. Metadata Backups</a:t>
-            </a:r>
-          </a:p>
-        </p:txBody>
-      </p:sp>
-      <p:sp>
-        <p:nvSpPr>
-          <p:cNvPr id="7" name="TextBox 6"/>
-          <p:cNvSpPr txBox="1"/>
-          <p:nvPr/>
-        </p:nvSpPr>
-        <p:spPr>
-          <a:xfrm>
-            <a:off x="457200" y="4023360"/>
-            <a:ext cx="10972800" cy="731520"/>
-          </a:xfrm>
-          <a:prstGeom prst="rect">
-            <a:avLst/>
-          </a:prstGeom>
-          <a:noFill/>
-        </p:spPr>
-        <p:txBody>
-          <a:bodyPr wrap="none">
-            <a:spAutoFit/>
-          </a:bodyPr>
-          <a:lstStyle/>
-          <a:p>
-            <a:pPr algn="l"/>
-          </a:p>
-          <a:p>
-            <a:pPr algn="l"/>
-            <a:r>
-              <a:rPr sz="1800" b="0">
-                <a:solidFill>
-                  <a:srgbClr val="16202E"/>
-                </a:solidFill>
-                <a:latin typeface="Open Sans"/>
-              </a:rPr>
-              <a:t>All dataset policies are versioned in `gs://bq-admin-backup/backups/` before any change is made.</a:t>
-            </a:r>
-          </a:p>
-        </p:txBody>
-      </p:sp>
-      <p:sp>
-        <p:nvSpPr>
-          <p:cNvPr id="8" name="TextBox 7"/>
-          <p:cNvSpPr txBox="1"/>
-          <p:nvPr/>
-        </p:nvSpPr>
-        <p:spPr>
-          <a:xfrm>
-            <a:off x="457200" y="5029200"/>
-            <a:ext cx="10972800" cy="457200"/>
-          </a:xfrm>
-          <a:prstGeom prst="rect">
-            <a:avLst/>
-          </a:prstGeom>
-          <a:noFill/>
-        </p:spPr>
-        <p:txBody>
-          <a:bodyPr wrap="none">
-            <a:spAutoFit/>
-          </a:bodyPr>
-          <a:lstStyle/>
-          <a:p>
-            <a:pPr algn="l"/>
-          </a:p>
-          <a:p>
-            <a:pPr algn="l"/>
-            <a:r>
-              <a:rPr sz="2400" b="1">
-                <a:solidFill>
-                  <a:srgbClr val="1A73E8"/>
-                </a:solidFill>
-                <a:latin typeface="Montserrat"/>
-              </a:rPr>
-              <a:t>3. Org-Level Access</a:t>
-            </a:r>
-          </a:p>
-        </p:txBody>
-      </p:sp>
-      <p:sp>
-        <p:nvSpPr>
-          <p:cNvPr id="9" name="TextBox 8"/>
-          <p:cNvSpPr txBox="1"/>
-          <p:nvPr/>
-        </p:nvSpPr>
-        <p:spPr>
-          <a:xfrm>
-            <a:off x="457200" y="5394960"/>
-            <a:ext cx="10972800" cy="731520"/>
-          </a:xfrm>
-          <a:prstGeom prst="rect">
-            <a:avLst/>
-          </a:prstGeom>
-          <a:noFill/>
-        </p:spPr>
-        <p:txBody>
-          <a:bodyPr wrap="none">
-            <a:spAutoFit/>
-          </a:bodyPr>
-          <a:lstStyle/>
-          <a:p>
-            <a:pPr algn="l"/>
-          </a:p>
-          <a:p>
-            <a:pPr algn="l"/>
-            <a:r>
-              <a:rPr sz="1800" b="0">
-                <a:solidFill>
-                  <a:srgbClr val="16202E"/>
-                </a:solidFill>
-                <a:latin typeface="Open Sans"/>
-              </a:rPr>
-              <a:t>Org Admins retain persistence via Org-level IAM. You are never locked out of managing the resource.</a:t>
-            </a:r>
-          </a:p>
-        </p:txBody>
-      </p:sp>
+        </p:nvGraphicFramePr>
+        <p:xfrm>
+          <a:off x="457200" y="1371600"/>
+          <a:ext cx="10972800" cy="4572000"/>
+        </p:xfrm>
+        <a:graphic>
+          <a:graphicData uri="http://schemas.openxmlformats.org/drawingml/2006/table">
+            <a:tbl>
+              <a:tblPr firstRow="1" bandRow="1">
+                <a:tableStyleId>{5C22544A-7EE6-4342-B048-85BDC9FD1C3A}</a:tableStyleId>
+              </a:tblPr>
+              <a:tblGrid>
+                <a:gridCol w="2194560"/>
+                <a:gridCol w="2194560"/>
+                <a:gridCol w="2194560"/>
+                <a:gridCol w="2194560"/>
+                <a:gridCol w="2194560"/>
+              </a:tblGrid>
+              <a:tr h="571500">
+                <a:tc>
+                  <a:txBody>
+                    <a:bodyPr/>
+                    <a:lstStyle/>
+                    <a:p>
+                      <a:pPr>
+                        <a:defRPr b="1">
+                          <a:solidFill>
+                            <a:srgbClr val="FFFFFF"/>
+                          </a:solidFill>
+                        </a:defRPr>
+                      </a:pPr>
+                      <a:r>
+                        <a:t>Tranche</a:t>
+                      </a:r>
+                    </a:p>
+                  </a:txBody>
+                  <a:tcPr>
+                    <a:solidFill>
+                      <a:srgbClr val="16202E"/>
+                    </a:solidFill>
+                  </a:tcPr>
+                </a:tc>
+                <a:tc>
+                  <a:txBody>
+                    <a:bodyPr/>
+                    <a:lstStyle/>
+                    <a:p>
+                      <a:pPr>
+                        <a:defRPr b="1">
+                          <a:solidFill>
+                            <a:srgbClr val="FFFFFF"/>
+                          </a:solidFill>
+                        </a:defRPr>
+                      </a:pPr>
+                      <a:r>
+                        <a:t>Cost/Mo ($)</a:t>
+                      </a:r>
+                    </a:p>
+                  </a:txBody>
+                  <a:tcPr>
+                    <a:solidFill>
+                      <a:srgbClr val="16202E"/>
+                    </a:solidFill>
+                  </a:tcPr>
+                </a:tc>
+                <a:tc>
+                  <a:txBody>
+                    <a:bodyPr/>
+                    <a:lstStyle/>
+                    <a:p>
+                      <a:pPr>
+                        <a:defRPr b="1">
+                          <a:solidFill>
+                            <a:srgbClr val="FFFFFF"/>
+                          </a:solidFill>
+                        </a:defRPr>
+                      </a:pPr>
+                      <a:r>
+                        <a:t>Volume (GB)</a:t>
+                      </a:r>
+                    </a:p>
+                  </a:txBody>
+                  <a:tcPr>
+                    <a:solidFill>
+                      <a:srgbClr val="16202E"/>
+                    </a:solidFill>
+                  </a:tcPr>
+                </a:tc>
+                <a:tc>
+                  <a:txBody>
+                    <a:bodyPr/>
+                    <a:lstStyle/>
+                    <a:p>
+                      <a:pPr>
+                        <a:defRPr b="1">
+                          <a:solidFill>
+                            <a:srgbClr val="FFFFFF"/>
+                          </a:solidFill>
+                        </a:defRPr>
+                      </a:pPr>
+                      <a:r>
+                        <a:t>Datasets</a:t>
+                      </a:r>
+                    </a:p>
+                  </a:txBody>
+                  <a:tcPr>
+                    <a:solidFill>
+                      <a:srgbClr val="16202E"/>
+                    </a:solidFill>
+                  </a:tcPr>
+                </a:tc>
+                <a:tc>
+                  <a:txBody>
+                    <a:bodyPr/>
+                    <a:lstStyle/>
+                    <a:p>
+                      <a:pPr>
+                        <a:defRPr b="1">
+                          <a:solidFill>
+                            <a:srgbClr val="FFFFFF"/>
+                          </a:solidFill>
+                        </a:defRPr>
+                      </a:pPr>
+                      <a:r>
+                        <a:t>Projects</a:t>
+                      </a:r>
+                    </a:p>
+                  </a:txBody>
+                  <a:tcPr>
+                    <a:solidFill>
+                      <a:srgbClr val="16202E"/>
+                    </a:solidFill>
+                  </a:tcPr>
+                </a:tc>
+              </a:tr>
+              <a:tr h="571500">
+                <a:tc>
+                  <a:txBody>
+                    <a:bodyPr/>
+                    <a:lstStyle/>
+                    <a:p>
+                      <a:pPr>
+                        <a:defRPr sz="1600"/>
+                      </a:pPr>
+                      <a:r>
+                        <a:t>T1: Abandoned Test</a:t>
+                      </a:r>
+                    </a:p>
+                  </a:txBody>
+                  <a:tcPr/>
+                </a:tc>
+                <a:tc>
+                  <a:txBody>
+                    <a:bodyPr/>
+                    <a:lstStyle/>
+                    <a:p>
+                      <a:pPr>
+                        <a:defRPr sz="1600"/>
+                      </a:pPr>
+                      <a:r>
+                        <a:t>549.90</a:t>
+                      </a:r>
+                    </a:p>
+                  </a:txBody>
+                  <a:tcPr/>
+                </a:tc>
+                <a:tc>
+                  <a:txBody>
+                    <a:bodyPr/>
+                    <a:lstStyle/>
+                    <a:p>
+                      <a:pPr>
+                        <a:defRPr sz="1600"/>
+                      </a:pPr>
+                      <a:r>
+                        <a:t>27,494</a:t>
+                      </a:r>
+                    </a:p>
+                  </a:txBody>
+                  <a:tcPr/>
+                </a:tc>
+                <a:tc>
+                  <a:txBody>
+                    <a:bodyPr/>
+                    <a:lstStyle/>
+                    <a:p>
+                      <a:pPr>
+                        <a:defRPr sz="1600"/>
+                      </a:pPr>
+                      <a:r>
+                        <a:t>37</a:t>
+                      </a:r>
+                    </a:p>
+                  </a:txBody>
+                  <a:tcPr/>
+                </a:tc>
+                <a:tc>
+                  <a:txBody>
+                    <a:bodyPr/>
+                    <a:lstStyle/>
+                    <a:p>
+                      <a:pPr>
+                        <a:defRPr sz="1600"/>
+                      </a:pPr>
+                      <a:r>
+                        <a:t>6</a:t>
+                      </a:r>
+                    </a:p>
+                  </a:txBody>
+                  <a:tcPr/>
+                </a:tc>
+              </a:tr>
+              <a:tr h="571500">
+                <a:tc>
+                  <a:txBody>
+                    <a:bodyPr/>
+                    <a:lstStyle/>
+                    <a:p>
+                      <a:pPr>
+                        <a:defRPr sz="1600"/>
+                      </a:pPr>
+                      <a:r>
+                        <a:t>T2: Abandoned Prod</a:t>
+                      </a:r>
+                    </a:p>
+                  </a:txBody>
+                  <a:tcPr/>
+                </a:tc>
+                <a:tc>
+                  <a:txBody>
+                    <a:bodyPr/>
+                    <a:lstStyle/>
+                    <a:p>
+                      <a:pPr>
+                        <a:defRPr sz="1600"/>
+                      </a:pPr>
+                      <a:r>
+                        <a:t>8,913.59</a:t>
+                      </a:r>
+                    </a:p>
+                  </a:txBody>
+                  <a:tcPr/>
+                </a:tc>
+                <a:tc>
+                  <a:txBody>
+                    <a:bodyPr/>
+                    <a:lstStyle/>
+                    <a:p>
+                      <a:pPr>
+                        <a:defRPr sz="1600"/>
+                      </a:pPr>
+                      <a:r>
+                        <a:t>445,681</a:t>
+                      </a:r>
+                    </a:p>
+                  </a:txBody>
+                  <a:tcPr/>
+                </a:tc>
+                <a:tc>
+                  <a:txBody>
+                    <a:bodyPr/>
+                    <a:lstStyle/>
+                    <a:p>
+                      <a:pPr>
+                        <a:defRPr sz="1600"/>
+                      </a:pPr>
+                      <a:r>
+                        <a:t>174</a:t>
+                      </a:r>
+                    </a:p>
+                  </a:txBody>
+                  <a:tcPr/>
+                </a:tc>
+                <a:tc>
+                  <a:txBody>
+                    <a:bodyPr/>
+                    <a:lstStyle/>
+                    <a:p>
+                      <a:pPr>
+                        <a:defRPr sz="1600"/>
+                      </a:pPr>
+                      <a:r>
+                        <a:t>11</a:t>
+                      </a:r>
+                    </a:p>
+                  </a:txBody>
+                  <a:tcPr/>
+                </a:tc>
+              </a:tr>
+              <a:tr h="571500">
+                <a:tc>
+                  <a:txBody>
+                    <a:bodyPr/>
+                    <a:lstStyle/>
+                    <a:p>
+                      <a:pPr>
+                        <a:defRPr sz="1600"/>
+                      </a:pPr>
+                      <a:r>
+                        <a:t>T3: Small Abandoned</a:t>
+                      </a:r>
+                    </a:p>
+                  </a:txBody>
+                  <a:tcPr/>
+                </a:tc>
+                <a:tc>
+                  <a:txBody>
+                    <a:bodyPr/>
+                    <a:lstStyle/>
+                    <a:p>
+                      <a:pPr>
+                        <a:defRPr sz="1600"/>
+                      </a:pPr>
+                      <a:r>
+                        <a:t>227.33</a:t>
+                      </a:r>
+                    </a:p>
+                  </a:txBody>
+                  <a:tcPr/>
+                </a:tc>
+                <a:tc>
+                  <a:txBody>
+                    <a:bodyPr/>
+                    <a:lstStyle/>
+                    <a:p>
+                      <a:pPr>
+                        <a:defRPr sz="1600"/>
+                      </a:pPr>
+                      <a:r>
+                        <a:t>11,372</a:t>
+                      </a:r>
+                    </a:p>
+                  </a:txBody>
+                  <a:tcPr/>
+                </a:tc>
+                <a:tc>
+                  <a:txBody>
+                    <a:bodyPr/>
+                    <a:lstStyle/>
+                    <a:p>
+                      <a:pPr>
+                        <a:defRPr sz="1600"/>
+                      </a:pPr>
+                      <a:r>
+                        <a:t>1,010</a:t>
+                      </a:r>
+                    </a:p>
+                  </a:txBody>
+                  <a:tcPr/>
+                </a:tc>
+                <a:tc>
+                  <a:txBody>
+                    <a:bodyPr/>
+                    <a:lstStyle/>
+                    <a:p>
+                      <a:pPr>
+                        <a:defRPr sz="1600"/>
+                      </a:pPr>
+                      <a:r>
+                        <a:t>15</a:t>
+                      </a:r>
+                    </a:p>
+                  </a:txBody>
+                  <a:tcPr/>
+                </a:tc>
+              </a:tr>
+              <a:tr h="571500">
+                <a:tc>
+                  <a:txBody>
+                    <a:bodyPr/>
+                    <a:lstStyle/>
+                    <a:p>
+                      <a:pPr>
+                        <a:defRPr sz="1600"/>
+                      </a:pPr>
+                      <a:r>
+                        <a:t>T4: Stale (180d)</a:t>
+                      </a:r>
+                    </a:p>
+                  </a:txBody>
+                  <a:tcPr/>
+                </a:tc>
+                <a:tc>
+                  <a:txBody>
+                    <a:bodyPr/>
+                    <a:lstStyle/>
+                    <a:p>
+                      <a:pPr>
+                        <a:defRPr sz="1600"/>
+                      </a:pPr>
+                      <a:r>
+                        <a:t>103.68</a:t>
+                      </a:r>
+                    </a:p>
+                  </a:txBody>
+                  <a:tcPr/>
+                </a:tc>
+                <a:tc>
+                  <a:txBody>
+                    <a:bodyPr/>
+                    <a:lstStyle/>
+                    <a:p>
+                      <a:pPr>
+                        <a:defRPr sz="1600"/>
+                      </a:pPr>
+                      <a:r>
+                        <a:t>5,182</a:t>
+                      </a:r>
+                    </a:p>
+                  </a:txBody>
+                  <a:tcPr/>
+                </a:tc>
+                <a:tc>
+                  <a:txBody>
+                    <a:bodyPr/>
+                    <a:lstStyle/>
+                    <a:p>
+                      <a:pPr>
+                        <a:defRPr sz="1600"/>
+                      </a:pPr>
+                      <a:r>
+                        <a:t>39</a:t>
+                      </a:r>
+                    </a:p>
+                  </a:txBody>
+                  <a:tcPr/>
+                </a:tc>
+                <a:tc>
+                  <a:txBody>
+                    <a:bodyPr/>
+                    <a:lstStyle/>
+                    <a:p>
+                      <a:pPr>
+                        <a:defRPr sz="1600"/>
+                      </a:pPr>
+                      <a:r>
+                        <a:t>9</a:t>
+                      </a:r>
+                    </a:p>
+                  </a:txBody>
+                  <a:tcPr/>
+                </a:tc>
+              </a:tr>
+              <a:tr h="571500">
+                <a:tc>
+                  <a:txBody>
+                    <a:bodyPr/>
+                    <a:lstStyle/>
+                    <a:p>
+                      <a:pPr>
+                        <a:defRPr sz="1600"/>
+                      </a:pPr>
+                      <a:r>
+                        <a:t>T5: Active Test</a:t>
+                      </a:r>
+                    </a:p>
+                  </a:txBody>
+                  <a:tcPr/>
+                </a:tc>
+                <a:tc>
+                  <a:txBody>
+                    <a:bodyPr/>
+                    <a:lstStyle/>
+                    <a:p>
+                      <a:pPr>
+                        <a:defRPr sz="1600"/>
+                      </a:pPr>
+                      <a:r>
+                        <a:t>581.07</a:t>
+                      </a:r>
+                    </a:p>
+                  </a:txBody>
+                  <a:tcPr/>
+                </a:tc>
+                <a:tc>
+                  <a:txBody>
+                    <a:bodyPr/>
+                    <a:lstStyle/>
+                    <a:p>
+                      <a:pPr>
+                        <a:defRPr sz="1600"/>
+                      </a:pPr>
+                      <a:r>
+                        <a:t>29,053</a:t>
+                      </a:r>
+                    </a:p>
+                  </a:txBody>
+                  <a:tcPr/>
+                </a:tc>
+                <a:tc>
+                  <a:txBody>
+                    <a:bodyPr/>
+                    <a:lstStyle/>
+                    <a:p>
+                      <a:pPr>
+                        <a:defRPr sz="1600"/>
+                      </a:pPr>
+                      <a:r>
+                        <a:t>49</a:t>
+                      </a:r>
+                    </a:p>
+                  </a:txBody>
+                  <a:tcPr/>
+                </a:tc>
+                <a:tc>
+                  <a:txBody>
+                    <a:bodyPr/>
+                    <a:lstStyle/>
+                    <a:p>
+                      <a:pPr>
+                        <a:defRPr sz="1600"/>
+                      </a:pPr>
+                      <a:r>
+                        <a:t>12</a:t>
+                      </a:r>
+                    </a:p>
+                  </a:txBody>
+                  <a:tcPr/>
+                </a:tc>
+              </a:tr>
+              <a:tr h="571500">
+                <a:tc>
+                  <a:txBody>
+                    <a:bodyPr/>
+                    <a:lstStyle/>
+                    <a:p>
+                      <a:pPr>
+                        <a:defRPr sz="1600" b="1"/>
+                      </a:pPr>
+                      <a:r>
+                        <a:t>Subtotal (Cleanup)</a:t>
+                      </a:r>
+                    </a:p>
+                  </a:txBody>
+                  <a:tcPr>
+                    <a:solidFill>
+                      <a:srgbClr val="F0F0F0"/>
+                    </a:solidFill>
+                  </a:tcPr>
+                </a:tc>
+                <a:tc>
+                  <a:txBody>
+                    <a:bodyPr/>
+                    <a:lstStyle/>
+                    <a:p>
+                      <a:pPr>
+                        <a:defRPr sz="1600"/>
+                      </a:pPr>
+                      <a:r>
+                        <a:t>10,375.57</a:t>
+                      </a:r>
+                    </a:p>
+                  </a:txBody>
+                  <a:tcPr/>
+                </a:tc>
+                <a:tc>
+                  <a:txBody>
+                    <a:bodyPr/>
+                    <a:lstStyle/>
+                    <a:p>
+                      <a:pPr>
+                        <a:defRPr sz="1600"/>
+                      </a:pPr>
+                      <a:r>
+                        <a:t>518,782</a:t>
+                      </a:r>
+                    </a:p>
+                  </a:txBody>
+                  <a:tcPr/>
+                </a:tc>
+                <a:tc>
+                  <a:txBody>
+                    <a:bodyPr/>
+                    <a:lstStyle/>
+                    <a:p>
+                      <a:pPr>
+                        <a:defRPr sz="1600"/>
+                      </a:pPr>
+                      <a:r>
+                        <a:t>1,309</a:t>
+                      </a:r>
+                    </a:p>
+                  </a:txBody>
+                  <a:tcPr/>
+                </a:tc>
+                <a:tc>
+                  <a:txBody>
+                    <a:bodyPr/>
+                    <a:lstStyle/>
+                    <a:p>
+                      <a:pPr>
+                        <a:defRPr sz="1600"/>
+                      </a:pPr>
+                      <a:r>
+                        <a:t>53</a:t>
+                      </a:r>
+                    </a:p>
+                  </a:txBody>
+                  <a:tcPr/>
+                </a:tc>
+              </a:tr>
+              <a:tr h="571500">
+                <a:tc>
+                  <a:txBody>
+                    <a:bodyPr/>
+                    <a:lstStyle/>
+                    <a:p>
+                      <a:pPr>
+                        <a:defRPr sz="1600"/>
+                      </a:pPr>
+                      <a:r>
+                        <a:t>Active (Prod)</a:t>
+                      </a:r>
+                    </a:p>
+                  </a:txBody>
+                  <a:tcPr/>
+                </a:tc>
+                <a:tc>
+                  <a:txBody>
+                    <a:bodyPr/>
+                    <a:lstStyle/>
+                    <a:p>
+                      <a:pPr>
+                        <a:defRPr sz="1600"/>
+                      </a:pPr>
+                      <a:r>
+                        <a:t>32,906.12</a:t>
+                      </a:r>
+                    </a:p>
+                  </a:txBody>
+                  <a:tcPr/>
+                </a:tc>
+                <a:tc>
+                  <a:txBody>
+                    <a:bodyPr/>
+                    <a:lstStyle/>
+                    <a:p>
+                      <a:pPr>
+                        <a:defRPr sz="1600"/>
+                      </a:pPr>
+                      <a:r>
+                        <a:t>1,645,314</a:t>
+                      </a:r>
+                    </a:p>
+                  </a:txBody>
+                  <a:tcPr/>
+                </a:tc>
+                <a:tc>
+                  <a:txBody>
+                    <a:bodyPr/>
+                    <a:lstStyle/>
+                    <a:p>
+                      <a:pPr>
+                        <a:defRPr sz="1600"/>
+                      </a:pPr>
+                      <a:r>
+                        <a:t>788</a:t>
+                      </a:r>
+                    </a:p>
+                  </a:txBody>
+                  <a:tcPr/>
+                </a:tc>
+                <a:tc>
+                  <a:txBody>
+                    <a:bodyPr/>
+                    <a:lstStyle/>
+                    <a:p>
+                      <a:pPr>
+                        <a:defRPr sz="1600"/>
+                      </a:pPr>
+                      <a:r>
+                        <a:t>28</a:t>
+                      </a:r>
+                    </a:p>
+                  </a:txBody>
+                  <a:tcPr/>
+                </a:tc>
+              </a:tr>
+            </a:tbl>
+          </a:graphicData>
+        </a:graphic>
+      </p:graphicFrame>
     </p:spTree>
   </p:cSld>
   <p:clrMapOvr>
@@ -3901,154 +4286,163 @@
                 </a:solidFill>
                 <a:latin typeface="Montserrat"/>
               </a:rPr>
-              <a:t>Operational Recovery Guide</a:t>
-            </a:r>
-          </a:p>
-        </p:txBody>
-      </p:sp>
-      <p:sp>
-        <p:nvSpPr>
-          <p:cNvPr id="3" name="Rectangle 2"/>
-          <p:cNvSpPr/>
+              <a:t>Access Profiles &amp; Cleanup Risk</a:t>
+            </a:r>
+          </a:p>
+        </p:txBody>
+      </p:sp>
+      <p:sp>
+        <p:nvSpPr>
+          <p:cNvPr id="3" name="TextBox 2"/>
+          <p:cNvSpPr txBox="1"/>
           <p:nvPr/>
         </p:nvSpPr>
         <p:spPr>
           <a:xfrm>
-            <a:off x="914400" y="1645920"/>
-            <a:ext cx="10332720" cy="4114800"/>
+            <a:off x="457200" y="1371600"/>
+            <a:ext cx="5486400" cy="4572000"/>
           </a:xfrm>
           <a:prstGeom prst="rect">
             <a:avLst/>
           </a:prstGeom>
-          <a:solidFill>
-            <a:srgbClr val="16202E"/>
-          </a:solidFill>
-          <a:ln>
-            <a:solidFill>
-              <a:srgbClr val="1A73E8"/>
-            </a:solidFill>
-          </a:ln>
+          <a:noFill/>
         </p:spPr>
-        <p:style>
-          <a:lnRef idx="1">
-            <a:schemeClr val="accent1"/>
-          </a:lnRef>
-          <a:fillRef idx="3">
-            <a:schemeClr val="accent1"/>
-          </a:fillRef>
-          <a:effectRef idx="2">
-            <a:schemeClr val="accent1"/>
-          </a:effectRef>
-          <a:fontRef idx="minor">
-            <a:schemeClr val="lt1"/>
-          </a:fontRef>
-        </p:style>
-        <p:txBody>
-          <a:bodyPr rtlCol="0" anchor="ctr"/>
-          <a:lstStyle/>
-          <a:p>
-            <a:pPr algn="l"/>
-            <a:r>
-              <a:rPr sz="2000" b="0">
+        <p:txBody>
+          <a:bodyPr wrap="none">
+            <a:spAutoFit/>
+          </a:bodyPr>
+          <a:lstStyle/>
+          <a:p/>
+          <a:p>
+            <a:pPr>
+              <a:defRPr b="1" sz="2400"/>
+            </a:pPr>
+            <a:r>
+              <a:t>Key Account Profiles Identified:</a:t>
+            </a:r>
+          </a:p>
+          <a:p>
+            <a:pPr>
+              <a:spcBef>
+                <a:spcPts val="1000"/>
+              </a:spcBef>
+              <a:defRPr sz="1800"/>
+            </a:pPr>
+            <a:r>
+              <a:t>· Service Accounts: finops-scheduler, quota-collector, argus-investigator</a:t>
+            </a:r>
+          </a:p>
+          <a:p>
+            <a:pPr>
+              <a:spcBef>
+                <a:spcPts val="1000"/>
+              </a:spcBef>
+              <a:defRPr sz="1800"/>
+            </a:pPr>
+            <a:r>
+              <a:t>· WIF Principals: GitHub Actions (thg-finops-prod)</a:t>
+            </a:r>
+          </a:p>
+          <a:p>
+            <a:pPr>
+              <a:spcBef>
+                <a:spcPts val="1000"/>
+              </a:spcBef>
+              <a:defRPr sz="1800"/>
+            </a:pPr>
+            <a:r>
+              <a:t>· User Groups: Data &amp; AI (Looker), FinOps Team, Product Owners</a:t>
+            </a:r>
+          </a:p>
+          <a:p>
+            <a:pPr>
+              <a:spcBef>
+                <a:spcPts val="1000"/>
+              </a:spcBef>
+              <a:defRPr sz="1800"/>
+            </a:pPr>
+            <a:r>
+              <a:t>· Orphaned: 1,300+ datasets have ZERO write activity in 180+ days</a:t>
+            </a:r>
+          </a:p>
+        </p:txBody>
+      </p:sp>
+      <p:sp>
+        <p:nvSpPr>
+          <p:cNvPr id="4" name="TextBox 3"/>
+          <p:cNvSpPr txBox="1"/>
+          <p:nvPr/>
+        </p:nvSpPr>
+        <p:spPr>
+          <a:xfrm>
+            <a:off x="6400800" y="1371600"/>
+            <a:ext cx="5029200" cy="4572000"/>
+          </a:xfrm>
+          <a:prstGeom prst="rect">
+            <a:avLst/>
+          </a:prstGeom>
+          <a:noFill/>
+        </p:spPr>
+        <p:txBody>
+          <a:bodyPr wrap="none">
+            <a:spAutoFit/>
+          </a:bodyPr>
+          <a:lstStyle/>
+          <a:p/>
+          <a:p>
+            <a:pPr>
+              <a:defRPr b="1" sz="2400">
                 <a:solidFill>
-                  <a:srgbClr val="FFFFFF"/>
+                  <a:srgbClr val="1A73E8"/>
                 </a:solidFill>
-                <a:latin typeface="Courier New"/>
-              </a:rPr>
-              <a:t># Restore a specific dataset</a:t>
-            </a:r>
-          </a:p>
-          <a:p>
-            <a:pPr algn="l"/>
-            <a:r>
-              <a:rPr sz="2000" b="0">
-                <a:solidFill>
-                  <a:srgbClr val="FFFFFF"/>
-                </a:solidFill>
-                <a:latin typeface="Courier New"/>
-              </a:rPr>
-              <a:t>python3 bq_restore_access.py --dataset project:dataset</a:t>
-            </a:r>
-          </a:p>
-          <a:p>
-            <a:pPr algn="l"/>
-          </a:p>
-          <a:p>
-            <a:pPr algn="l"/>
-            <a:r>
-              <a:rPr sz="2000" b="0">
-                <a:solidFill>
-                  <a:srgbClr val="FFFFFF"/>
-                </a:solidFill>
-                <a:latin typeface="Courier New"/>
-              </a:rPr>
-              <a:t># Restore an entire tranche (e.g., if a whole team 'screams')</a:t>
-            </a:r>
-          </a:p>
-          <a:p>
-            <a:pPr algn="l"/>
-            <a:r>
-              <a:rPr sz="2000" b="0">
-                <a:solidFill>
-                  <a:srgbClr val="FFFFFF"/>
-                </a:solidFill>
-                <a:latin typeface="Courier New"/>
-              </a:rPr>
-              <a:t>python3 bq_restore_access.py --tranche 1.1</a:t>
-            </a:r>
-          </a:p>
-          <a:p>
-            <a:pPr algn="l"/>
-          </a:p>
-          <a:p>
-            <a:pPr algn="l"/>
-            <a:r>
-              <a:rPr sz="2000" b="0">
-                <a:solidFill>
-                  <a:srgbClr val="FFFFFF"/>
-                </a:solidFill>
-                <a:latin typeface="Courier New"/>
-              </a:rPr>
-              <a:t># Emergency 'Undo' for all active scream tests</a:t>
-            </a:r>
-          </a:p>
-          <a:p>
-            <a:pPr algn="l"/>
-            <a:r>
-              <a:rPr sz="2000" b="0">
-                <a:solidFill>
-                  <a:srgbClr val="FFFFFF"/>
-                </a:solidFill>
-                <a:latin typeface="Courier New"/>
-              </a:rPr>
-              <a:t>python3 bq_restore_access.py --all</a:t>
-            </a:r>
-          </a:p>
-          <a:p>
-            <a:pPr algn="l"/>
-          </a:p>
-          <a:p>
-            <a:pPr algn="l"/>
-            <a:r>
-              <a:rPr sz="2000" b="0">
-                <a:solidFill>
-                  <a:srgbClr val="FFFFFF"/>
-                </a:solidFill>
-                <a:latin typeface="Courier New"/>
-              </a:rPr>
-              <a:t># Verify backup presence before restoration</a:t>
-            </a:r>
-          </a:p>
-          <a:p>
-            <a:pPr algn="l"/>
-            <a:r>
-              <a:rPr sz="2000" b="0">
-                <a:solidFill>
-                  <a:srgbClr val="FFFFFF"/>
-                </a:solidFill>
-                <a:latin typeface="Courier New"/>
-              </a:rPr>
-              <a:t>gsutil ls gs://bq-admin-backup/backups/</a:t>
+              </a:defRPr>
+            </a:pPr>
+            <a:r>
+              <a:t>Recent Activity (Last 24h):</a:t>
+            </a:r>
+          </a:p>
+          <a:p>
+            <a:pPr>
+              <a:spcBef>
+                <a:spcPts val="1000"/>
+              </a:spcBef>
+              <a:defRPr sz="1800"/>
+            </a:pPr>
+            <a:r>
+              <a:t>· thg-data-personify: Personify (Active)</a:t>
+            </a:r>
+          </a:p>
+          <a:p>
+            <a:pPr>
+              <a:spcBef>
+                <a:spcPts val="1000"/>
+              </a:spcBef>
+              <a:defRPr sz="1800"/>
+            </a:pPr>
+            <a:r>
+              <a:t>· thg-ingenuity: analytics_376116958 (Active)</a:t>
+            </a:r>
+          </a:p>
+          <a:p>
+            <a:pPr>
+              <a:spcBef>
+                <a:spcPts val="1000"/>
+              </a:spcBef>
+              <a:defRPr sz="1800"/>
+            </a:pPr>
+            <a:r>
+              <a:t>· thg-ml-dev: chatbot_conversations (Active)</a:t>
+            </a:r>
+          </a:p>
+          <a:p>
+            <a:pPr>
+              <a:spcBef>
+                <a:spcPts val="1000"/>
+              </a:spcBef>
+              <a:defRPr sz="1800"/>
+            </a:pPr>
+            <a:r>
+              <a:t>· thg-cx-data: hermes_events (Active)</a:t>
             </a:r>
           </a:p>
         </p:txBody>
@@ -4104,7 +4498,7 @@
                 </a:solidFill>
                 <a:latin typeface="Montserrat"/>
               </a:rPr>
-              <a:t>Targeted Savings &amp; Repository</a:t>
+              <a:t>Execution Control</a:t>
             </a:r>
           </a:p>
         </p:txBody>
@@ -4118,7 +4512,7 @@
         <p:spPr>
           <a:xfrm>
             <a:off x="457200" y="1828800"/>
-            <a:ext cx="10972800" cy="3200400"/>
+            <a:ext cx="10972800" cy="3657600"/>
           </a:xfrm>
           <a:prstGeom prst="rect">
             <a:avLst/>
@@ -4134,60 +4528,50 @@
             <a:pPr algn="l"/>
           </a:p>
           <a:p>
-            <a:pPr algn="l"/>
-            <a:r>
-              <a:rPr sz="3200" b="0">
+            <a:pPr algn="l">
+              <a:defRPr b="1"/>
+            </a:pPr>
+            <a:r>
+              <a:rPr sz="2800" b="0">
                 <a:solidFill>
                   <a:srgbClr val="16202E"/>
                 </a:solidFill>
                 <a:latin typeface="Open Sans"/>
               </a:rPr>
-              <a:t>Audit complete across 50+ projects.</a:t>
+              <a:t>Control File: 20260624_Data_Estate_Cleanup_Audit.xlsx</a:t>
             </a:r>
           </a:p>
           <a:p>
             <a:pPr algn="l"/>
             <a:r>
-              <a:rPr sz="3200" b="0">
+              <a:rPr sz="2800" b="0">
                 <a:solidFill>
                   <a:srgbClr val="16202E"/>
                 </a:solidFill>
                 <a:latin typeface="Open Sans"/>
               </a:rPr>
-              <a:t>Identified 120+ Stale/Abandoned datasets (Tranche 1-3).</a:t>
-            </a:r>
-          </a:p>
-          <a:p>
+              <a:t>Targeting 1,300+ datasets with $10k+ monthly waste potential.</a:t>
+            </a:r>
+          </a:p>
+          <a:p>
+            <a:br/>
             <a:pPr algn="l"/>
             <a:r>
-              <a:rPr sz="3200" b="0">
+              <a:rPr sz="2800" b="0">
                 <a:solidFill>
                   <a:srgbClr val="16202E"/>
                 </a:solidFill>
                 <a:latin typeface="Open Sans"/>
               </a:rPr>
-              <a:t>Estimated annual savings: $28,400+ (Stale Data Storage Only).</a:t>
-            </a:r>
-          </a:p>
-          <a:p>
-            <a:br/>
+              <a:t>Code &amp; Full Audit Control Repository:</a:t>
+            </a:r>
+          </a:p>
+          <a:p>
             <a:pPr algn="l"/>
             <a:r>
               <a:rPr sz="2400" b="1">
                 <a:solidFill>
                   <a:srgbClr val="1A73E8"/>
-                </a:solidFill>
-                <a:latin typeface="Open Sans"/>
-              </a:rPr>
-              <a:t>Code &amp; Documentation Repository:</a:t>
-            </a:r>
-          </a:p>
-          <a:p>
-            <a:pPr algn="l"/>
-            <a:r>
-              <a:rPr sz="3200" b="0">
-                <a:solidFill>
-                  <a:srgbClr val="16202E"/>
                 </a:solidFill>
                 <a:latin typeface="Open Sans"/>
               </a:rPr>

</xml_diff>